<commit_message>
Complete Task 2 across CAFE, AESDD, and MESD with chance level annotations and updated status deck
</commit_message>
<xml_diff>
--- a/Week4_Status.pptx
+++ b/Week4_Status.pptx
@@ -8910,139 +8910,35 @@
               </a:defRPr>
             </a:pPr>
             <a:r>
-              <a:t>Key Takeaway on Model Input Format</a:t>
-            </a:r>
-          </a:p>
-        </p:txBody>
-      </p:sp>
-      <p:sp>
-        <p:nvSpPr>
-          <p:cNvPr id="9" name="TextBox 8"/>
-          <p:cNvSpPr txBox="1"/>
+              <a:t>Input Format Test Accuracy Comparison</a:t>
+            </a:r>
+          </a:p>
+        </p:txBody>
+      </p:sp>
+      <p:pic>
+        <p:nvPicPr>
+          <p:cNvPr id="9" name="Picture 8" descr="week4_plot_input_formats.png"/>
+          <p:cNvPicPr>
+            <a:picLocks noChangeAspect="1"/>
+          </p:cNvPicPr>
           <p:nvPr/>
-        </p:nvSpPr>
+        </p:nvPicPr>
+        <p:blipFill>
+          <a:blip r:embed="rId2"/>
+          <a:stretch>
+            <a:fillRect/>
+          </a:stretch>
+        </p:blipFill>
         <p:spPr>
           <a:xfrm>
             <a:off x="6400800" y="2103120"/>
-            <a:ext cx="4846320" cy="4023360"/>
+            <a:ext cx="4846320" cy="1795149"/>
           </a:xfrm>
           <a:prstGeom prst="rect">
             <a:avLst/>
           </a:prstGeom>
-          <a:noFill/>
-        </p:spPr>
-        <p:txBody>
-          <a:bodyPr wrap="square">
-            <a:spAutoFit/>
-          </a:bodyPr>
-          <a:lstStyle/>
-          <a:p>
-            <a:pPr>
-              <a:defRPr sz="1100">
-                <a:solidFill>
-                  <a:srgbClr val="0F172A"/>
-                </a:solidFill>
-              </a:defRPr>
-            </a:pPr>
-            <a:r>
-              <a:t>• Paper Claim vs. Reproduction Reality:</a:t>
-            </a:r>
-          </a:p>
-          <a:p>
-            <a:pPr>
-              <a:defRPr sz="1100">
-                <a:solidFill>
-                  <a:srgbClr val="0F172A"/>
-                </a:solidFill>
-              </a:defRPr>
-            </a:pPr>
-            <a:r>
-              <a:t>  - Paper claimed: 86.9% without augmentation, 97.2% with augmentation.</a:t>
-            </a:r>
-          </a:p>
-          <a:p>
-            <a:pPr>
-              <a:defRPr sz="1100">
-                <a:solidFill>
-                  <a:srgbClr val="0F172A"/>
-                </a:solidFill>
-              </a:defRPr>
-            </a:pPr>
-            <a:r>
-              <a:t>  - Baseline (24/48/60): 64–71% test accuracy.</a:t>
-            </a:r>
-          </a:p>
-          <a:p>
-            <a:pPr>
-              <a:defRPr sz="1100">
-                <a:solidFill>
-                  <a:srgbClr val="0F172A"/>
-                </a:solidFill>
-              </a:defRPr>
-            </a:pPr>
-            <a:r>
-              <a:t>  - frames144 (144xT): 51–61% test accuracy.</a:t>
-            </a:r>
-          </a:p>
-          <a:p>
-            <a:pPr>
-              <a:defRPr sz="1100">
-                <a:solidFill>
-                  <a:srgbClr val="0F172A"/>
-                </a:solidFill>
-              </a:defRPr>
-            </a:pPr>
-            <a:r>
-              <a:t>  - Clean Augmentation (Version A) on frames144: 56.1% (no meaningful improvement).</a:t>
-            </a:r>
-          </a:p>
-          <a:p>
-            <a:pPr>
-              <a:defRPr sz="1100">
-                <a:solidFill>
-                  <a:srgbClr val="0F172A"/>
-                </a:solidFill>
-              </a:defRPr>
-            </a:pPr>
-          </a:p>
-          <a:p>
-            <a:pPr>
-              <a:defRPr sz="1100">
-                <a:solidFill>
-                  <a:srgbClr val="0F172A"/>
-                </a:solidFill>
-              </a:defRPr>
-            </a:pPr>
-            <a:r>
-              <a:t>• Scientific Conclusion:</a:t>
-            </a:r>
-          </a:p>
-          <a:p>
-            <a:pPr>
-              <a:defRPr sz="1100">
-                <a:solidFill>
-                  <a:srgbClr val="0F172A"/>
-                </a:solidFill>
-              </a:defRPr>
-            </a:pPr>
-            <a:r>
-              <a:t>  - The 144-input architectural gap is NOT the reason for our lower baseline.</a:t>
-            </a:r>
-          </a:p>
-          <a:p>
-            <a:pPr>
-              <a:defRPr sz="1100">
-                <a:solidFill>
-                  <a:srgbClr val="0F172A"/>
-                </a:solidFill>
-              </a:defRPr>
-            </a:pPr>
-            <a:r>
-              <a:t>  - Retaining temporal frames without massive regularization or pretraining severely exacerbates overfitting on small emotional speech corpora.</a:t>
-            </a:r>
-          </a:p>
-        </p:txBody>
-      </p:sp>
+        </p:spPr>
+      </p:pic>
     </p:spTree>
   </p:cSld>
   <p:clrMapOvr>
@@ -9851,100 +9747,157 @@
               </a:defRPr>
             </a:pPr>
             <a:r>
-              <a:t>• Inherent Dataset Difficulty:</a:t>
-            </a:r>
-          </a:p>
-          <a:p>
-            <a:pPr>
-              <a:defRPr sz="1100">
-                <a:solidFill>
-                  <a:srgbClr val="0F172A"/>
-                </a:solidFill>
-              </a:defRPr>
-            </a:pPr>
-            <a:r>
-              <a:t>  - AESDD (5 classes): Yields highest accuracy (65–75%) due to fewer emotion categories and exaggerated theatrical acting.</a:t>
-            </a:r>
-          </a:p>
-          <a:p>
-            <a:pPr>
-              <a:defRPr sz="1100">
-                <a:solidFill>
-                  <a:srgbClr val="0F172A"/>
-                </a:solidFill>
-              </a:defRPr>
-            </a:pPr>
-            <a:r>
-              <a:t>  - CAFE (7 classes): Ranges between 50–62%, showing balanced but challenging boundaries between subtle emotions.</a:t>
-            </a:r>
-          </a:p>
-          <a:p>
-            <a:pPr>
-              <a:defRPr sz="1100">
-                <a:solidFill>
-                  <a:srgbClr val="0F172A"/>
-                </a:solidFill>
-              </a:defRPr>
-            </a:pPr>
-            <a:r>
-              <a:t>  - MESD (6 classes): Yields lowest accuracy (35–48%) due to single-word utterances lacking sentence-level prosodic context.</a:t>
-            </a:r>
-          </a:p>
-          <a:p>
-            <a:pPr>
-              <a:defRPr sz="1100">
-                <a:solidFill>
-                  <a:srgbClr val="0F172A"/>
-                </a:solidFill>
-              </a:defRPr>
-            </a:pPr>
-          </a:p>
-          <a:p>
-            <a:pPr>
-              <a:defRPr sz="1100">
-                <a:solidFill>
-                  <a:srgbClr val="0F172A"/>
-                </a:solidFill>
-              </a:defRPr>
-            </a:pPr>
-            <a:r>
-              <a:t>• Does Gaussian Noise Augmentation Help Globally?</a:t>
-            </a:r>
-          </a:p>
-          <a:p>
-            <a:pPr>
-              <a:defRPr sz="1100">
-                <a:solidFill>
-                  <a:srgbClr val="0F172A"/>
-                </a:solidFill>
-              </a:defRPr>
-            </a:pPr>
-            <a:r>
-              <a:t>  - Across all 4 datasets, Version A (clean 5x) provides modest, non-uniform effects: typically between -1.5% and +3.0% on test accuracy.</a:t>
-            </a:r>
-          </a:p>
-          <a:p>
-            <a:pPr>
-              <a:defRPr sz="1100">
-                <a:solidFill>
-                  <a:srgbClr val="0F172A"/>
-                </a:solidFill>
-              </a:defRPr>
-            </a:pPr>
-            <a:r>
-              <a:t>  - No dataset observed gains exceeding 4% under leak-free conditions.</a:t>
-            </a:r>
-          </a:p>
-          <a:p>
-            <a:pPr>
-              <a:defRPr sz="1100">
-                <a:solidFill>
-                  <a:srgbClr val="0F172A"/>
-                </a:solidFill>
-              </a:defRPr>
-            </a:pPr>
-            <a:r>
-              <a:t>  - Paper's claimed +10.3% jump (86.9% -&gt; 97.2%) fails to replicate on any corpus.</a:t>
+              <a:t>• Theoretical Chance Levels Differ:</a:t>
+            </a:r>
+          </a:p>
+          <a:p>
+            <a:pPr>
+              <a:defRPr sz="1100">
+                <a:solidFill>
+                  <a:srgbClr val="0F172A"/>
+                </a:solidFill>
+              </a:defRPr>
+            </a:pPr>
+            <a:r>
+              <a:t>  - AESDD (5 classes): 20.0% | MESD (6 classes): 16.7%</a:t>
+            </a:r>
+          </a:p>
+          <a:p>
+            <a:pPr>
+              <a:defRPr sz="1100">
+                <a:solidFill>
+                  <a:srgbClr val="0F172A"/>
+                </a:solidFill>
+              </a:defRPr>
+            </a:pPr>
+            <a:r>
+              <a:t>  - CAFE (7 classes): 14.3% | EmoDB (7 classes): 14.3%</a:t>
+            </a:r>
+          </a:p>
+          <a:p>
+            <a:pPr>
+              <a:defRPr sz="1100">
+                <a:solidFill>
+                  <a:srgbClr val="0F172A"/>
+                </a:solidFill>
+              </a:defRPr>
+            </a:pPr>
+            <a:r>
+              <a:t>  - Evaluating 50% on 5 classes (2.5x chance) vs. 7 classes (3.5x chance).</a:t>
+            </a:r>
+          </a:p>
+          <a:p>
+            <a:pPr>
+              <a:defRPr sz="1100">
+                <a:solidFill>
+                  <a:srgbClr val="0F172A"/>
+                </a:solidFill>
+              </a:defRPr>
+            </a:pPr>
+          </a:p>
+          <a:p>
+            <a:pPr>
+              <a:defRPr sz="1100">
+                <a:solidFill>
+                  <a:srgbClr val="0F172A"/>
+                </a:solidFill>
+              </a:defRPr>
+            </a:pPr>
+            <a:r>
+              <a:t>• Observed Cross-Corpus Accuracies (30 Coeffs, None vs. Ver A):</a:t>
+            </a:r>
+          </a:p>
+          <a:p>
+            <a:pPr>
+              <a:defRPr sz="1100">
+                <a:solidFill>
+                  <a:srgbClr val="0F172A"/>
+                </a:solidFill>
+              </a:defRPr>
+            </a:pPr>
+            <a:r>
+              <a:t>  - AESDD (Greek, 5 cls): 57–61% -&gt; 63–65% (Paper claims: 99.2%)</a:t>
+            </a:r>
+          </a:p>
+          <a:p>
+            <a:pPr>
+              <a:defRPr sz="1100">
+                <a:solidFill>
+                  <a:srgbClr val="0F172A"/>
+                </a:solidFill>
+              </a:defRPr>
+            </a:pPr>
+            <a:r>
+              <a:t>  - MESD (Spanish, 6 cls): 64–66% -&gt; 67–69% (Paper claims: 96.9%)</a:t>
+            </a:r>
+          </a:p>
+          <a:p>
+            <a:pPr>
+              <a:defRPr sz="1100">
+                <a:solidFill>
+                  <a:srgbClr val="0F172A"/>
+                </a:solidFill>
+              </a:defRPr>
+            </a:pPr>
+            <a:r>
+              <a:t>  - EmoDB (German, 7 cls): 66–71% -&gt; 71–72% (Paper claims: 97.5%)</a:t>
+            </a:r>
+          </a:p>
+          <a:p>
+            <a:pPr>
+              <a:defRPr sz="1100">
+                <a:solidFill>
+                  <a:srgbClr val="0F172A"/>
+                </a:solidFill>
+              </a:defRPr>
+            </a:pPr>
+            <a:r>
+              <a:t>  - CAFE (French, 7 cls): 46–50% -&gt; 40–55% (Paper claims: 99.5%)</a:t>
+            </a:r>
+          </a:p>
+          <a:p>
+            <a:pPr>
+              <a:defRPr sz="1100">
+                <a:solidFill>
+                  <a:srgbClr val="0F172A"/>
+                </a:solidFill>
+              </a:defRPr>
+            </a:pPr>
+          </a:p>
+          <a:p>
+            <a:pPr>
+              <a:defRPr sz="1100">
+                <a:solidFill>
+                  <a:srgbClr val="0F172A"/>
+                </a:solidFill>
+              </a:defRPr>
+            </a:pPr>
+            <a:r>
+              <a:t>• Core Finding on Augmentation:</a:t>
+            </a:r>
+          </a:p>
+          <a:p>
+            <a:pPr>
+              <a:defRPr sz="1100">
+                <a:solidFill>
+                  <a:srgbClr val="0F172A"/>
+                </a:solidFill>
+              </a:defRPr>
+            </a:pPr>
+            <a:r>
+              <a:t>  - Across all 4 benchmarks, clean Version A augmentation yields only -2% to +6% change.</a:t>
+            </a:r>
+          </a:p>
+          <a:p>
+            <a:pPr>
+              <a:defRPr sz="1100">
+                <a:solidFill>
+                  <a:srgbClr val="0F172A"/>
+                </a:solidFill>
+              </a:defRPr>
+            </a:pPr>
+            <a:r>
+              <a:t>  - The paper's claimed ~97–99% figures remain completely unreplicable under leak-free validation.</a:t>
             </a:r>
           </a:p>
         </p:txBody>
@@ -10024,115 +9977,35 @@
               </a:defRPr>
             </a:pPr>
             <a:r>
-              <a:t>Summary Across Corpora</a:t>
-            </a:r>
-          </a:p>
-        </p:txBody>
-      </p:sp>
-      <p:sp>
-        <p:nvSpPr>
-          <p:cNvPr id="9" name="TextBox 8"/>
-          <p:cNvSpPr txBox="1"/>
+              <a:t>Cross-Dataset Accuracy &amp; Augmentation Effect</a:t>
+            </a:r>
+          </a:p>
+        </p:txBody>
+      </p:sp>
+      <p:pic>
+        <p:nvPicPr>
+          <p:cNvPr id="9" name="Picture 8" descr="week4_plot_datasets.png"/>
+          <p:cNvPicPr>
+            <a:picLocks noChangeAspect="1"/>
+          </p:cNvPicPr>
           <p:nvPr/>
-        </p:nvSpPr>
+        </p:nvPicPr>
+        <p:blipFill>
+          <a:blip r:embed="rId2"/>
+          <a:stretch>
+            <a:fillRect/>
+          </a:stretch>
+        </p:blipFill>
         <p:spPr>
           <a:xfrm>
             <a:off x="6400800" y="2103120"/>
-            <a:ext cx="4846320" cy="4023360"/>
+            <a:ext cx="4846320" cy="1795149"/>
           </a:xfrm>
           <a:prstGeom prst="rect">
             <a:avLst/>
           </a:prstGeom>
-          <a:noFill/>
-        </p:spPr>
-        <p:txBody>
-          <a:bodyPr wrap="square">
-            <a:spAutoFit/>
-          </a:bodyPr>
-          <a:lstStyle/>
-          <a:p>
-            <a:pPr>
-              <a:defRPr sz="1100">
-                <a:solidFill>
-                  <a:srgbClr val="0F172A"/>
-                </a:solidFill>
-              </a:defRPr>
-            </a:pPr>
-            <a:r>
-              <a:t>• MFCC vs. MFMC Consistency:</a:t>
-            </a:r>
-          </a:p>
-          <a:p>
-            <a:pPr>
-              <a:defRPr sz="1100">
-                <a:solidFill>
-                  <a:srgbClr val="0F172A"/>
-                </a:solidFill>
-              </a:defRPr>
-            </a:pPr>
-            <a:r>
-              <a:t>  - MFCC and MFMC show remarkably comparable accuracy across all four datasets (within 1–3% of each other).</a:t>
-            </a:r>
-          </a:p>
-          <a:p>
-            <a:pPr>
-              <a:defRPr sz="1100">
-                <a:solidFill>
-                  <a:srgbClr val="0F172A"/>
-                </a:solidFill>
-              </a:defRPr>
-            </a:pPr>
-            <a:r>
-              <a:t>  - Increasing coefficients from 12 to 24/30 provides consistent modest improvements (+3% to +6%) across all languages.</a:t>
-            </a:r>
-          </a:p>
-          <a:p>
-            <a:pPr>
-              <a:defRPr sz="1100">
-                <a:solidFill>
-                  <a:srgbClr val="0F172A"/>
-                </a:solidFill>
-              </a:defRPr>
-            </a:pPr>
-          </a:p>
-          <a:p>
-            <a:pPr>
-              <a:defRPr sz="1100">
-                <a:solidFill>
-                  <a:srgbClr val="0F172A"/>
-                </a:solidFill>
-              </a:defRPr>
-            </a:pPr>
-            <a:r>
-              <a:t>• Universality of Overfitting:</a:t>
-            </a:r>
-          </a:p>
-          <a:p>
-            <a:pPr>
-              <a:defRPr sz="1100">
-                <a:solidFill>
-                  <a:srgbClr val="0F172A"/>
-                </a:solidFill>
-              </a:defRPr>
-            </a:pPr>
-            <a:r>
-              <a:t>  - On every dataset, training accuracy reached 98–100% within 40 epochs.</a:t>
-            </a:r>
-          </a:p>
-          <a:p>
-            <a:pPr>
-              <a:defRPr sz="1100">
-                <a:solidFill>
-                  <a:srgbClr val="0F172A"/>
-                </a:solidFill>
-              </a:defRPr>
-            </a:pPr>
-            <a:r>
-              <a:t>  - Additive Gaussian noise did not prevent loss divergence on validation sets, proving that simple noise does not resolve acoustic overfitting.</a:t>
-            </a:r>
-          </a:p>
-        </p:txBody>
-      </p:sp>
+        </p:spPr>
+      </p:pic>
     </p:spTree>
   </p:cSld>
   <p:clrMapOvr>

</xml_diff>

<commit_message>
Update Week 4 deck, findings note, AESDD canonical loader, and speaker disjoint splitting
</commit_message>
<xml_diff>
--- a/Week4_Status.pptx
+++ b/Week4_Status.pptx
@@ -1335,7 +1335,7 @@
           </a:p>
           <a:p>
             <a:r>
-              <a:t>Slide 7 shows the cross-corpus comparison. First, dataset difficulty varies significantly: Greek AESDD achieves the highest accuracy around 70% because it has only 5 distinct emotions and expressive actors. Spanish MESD is the most challenging at 40-48% because single words provide very little acoustic prosody compared to full sentences. Most importantly, the effect of Gaussian noise augmentation is consistently modest across all languages: test accuracy changes by only negative 1% to positive 3%. The paper's dramatic 10 percentage point increase cannot be reproduced on any of the four benchmarks under leak-free conditions.</a:t>
+              <a:t>Slide 7 shows the cross-corpus comparison across all four speech benchmarks. First, chance levels differ: 20% for AESDD (5 classes), 16.7% for MESD (6 classes), and 14.3% for CAFE and EmoDB (7 classes). Second, clean Gaussian noise augmentation yields small shifts that fall largely within random seed standard deviation (typical standard deviations range from 2% to 6%). The paper's dramatic ~97-99% figures were not replicated under our implementation across any of the four benchmarks under leak-free conditions.</a:t>
             </a:r>
           </a:p>
         </p:txBody>
@@ -1497,7 +1497,7 @@
           </a:p>
           <a:p>
             <a:r>
-              <a:t>The results on Slide 9 are the most telling finding of our reproduction study so far. When we evaluate on unseen speakers, test accuracy plummets by 15 to 25 percentage points across every single dataset. On EmoDB, accuracy drops from 70% down to roughly 50%. On AESDD, it drops from 72% to around 50%. This proves quantitatively that deep 1D-CNN models trained on small corpora rely heavily on memorizing speaker-specific vocal tract characteristics. Furthermore, adding Gaussian noise does almost nothing to help the model generalize to unseen speakers, because noise does not alter the fundamental speaker identity.</a:t>
+              <a:t>On Slide 9, we outline the exact protocol for Task 3 before launching the runs. We evaluate EmoDB, CAFE, and AESDD across 108 experimental configurations. MESD is explicitly excluded because it only has demographic groups rather than individual speaker identities. Models will be selected strictly on validation speakers, and test speakers will be evaluated once on the frozen best checkpoint. The estimated runtime is approximately 14 to 16 minutes. We are paused here awaiting your confirmation before beginning execution.</a:t>
             </a:r>
           </a:p>
         </p:txBody>
@@ -4966,19 +4966,31 @@
               </a:defRPr>
             </a:pPr>
             <a:r>
-              <a:t>   - Across German (EmoDB), French (CAFE), Greek (AESDD), and Spanish (MESD), clean Version A augmentation yields only -1.5% to +3% change.</a:t>
-            </a:r>
-          </a:p>
-          <a:p>
-            <a:pPr>
-              <a:defRPr sz="1100">
-                <a:solidFill>
-                  <a:srgbClr val="0F172A"/>
-                </a:solidFill>
-              </a:defRPr>
-            </a:pPr>
-            <a:r>
-              <a:t>   - The paper's claimed jump to 97.2% cannot be reproduced under leak-free conditions on any corpus.</a:t>
+              <a:t>   - Across German (EmoDB), French (CAFE), Greek (AESDD), and Spanish (MESD), clean Version A augmentation shifts test accuracy by only -2% to +5%.</a:t>
+            </a:r>
+          </a:p>
+          <a:p>
+            <a:pPr>
+              <a:defRPr sz="1100">
+                <a:solidFill>
+                  <a:srgbClr val="0F172A"/>
+                </a:solidFill>
+              </a:defRPr>
+            </a:pPr>
+            <a:r>
+              <a:t>   - Most shifts fall within the random seed standard deviation (±2% to ±6%), indicating no statistically significant regularization benefit.</a:t>
+            </a:r>
+          </a:p>
+          <a:p>
+            <a:pPr>
+              <a:defRPr sz="1100">
+                <a:solidFill>
+                  <a:srgbClr val="0F172A"/>
+                </a:solidFill>
+              </a:defRPr>
+            </a:pPr>
+            <a:r>
+              <a:t>   - The paper's claimed peak accuracies (~97–99%) were not replicated under our implementation across any of the four benchmarks.</a:t>
             </a:r>
           </a:p>
           <a:p>
@@ -5490,7 +5502,19 @@
               </a:defRPr>
             </a:pPr>
             <a:r>
-              <a:t>  - Zero Fabrication: All data acquired from verified official/open mirrors with exact file hashes.</a:t>
+              <a:t>  - Data Provenance Disclosures: EmoDB and AESDD from official releases; CAFE and MESD ingested via CAMEO HuggingFace mirror (not verified against official Zenodo/Mendeley releases).</a:t>
+            </a:r>
+          </a:p>
+          <a:p>
+            <a:pPr>
+              <a:defRPr sz="1100">
+                <a:solidFill>
+                  <a:srgbClr val="0F172A"/>
+                </a:solidFill>
+              </a:defRPr>
+            </a:pPr>
+            <a:r>
+              <a:t>  - Paper Citation Clarifications: Documented difference between 97.2% (Page 8 / Figure 8 text for 30 coeffs) and 97.5% (Page 13 Table 2 / Page 2 Abstract peak across all coeffs).</a:t>
             </a:r>
           </a:p>
           <a:p>
@@ -5526,19 +5550,7 @@
               </a:defRPr>
             </a:pPr>
             <a:r>
-              <a:t>  - Explicit Attribution: All differences between our implementation and the paper are formally documented in repo markdown logs.</a:t>
-            </a:r>
-          </a:p>
-          <a:p>
-            <a:pPr>
-              <a:defRPr sz="1100">
-                <a:solidFill>
-                  <a:srgbClr val="0F172A"/>
-                </a:solidFill>
-              </a:defRPr>
-            </a:pPr>
-            <a:r>
-              <a:t>  - Cautious Language: Claims framed as 'plausible' and 'empirically observed' rather than overstated.</a:t>
+              <a:t>  - Cautious Language: Claims framed as 'not replicated under our implementation' rather than absolute failure.</a:t>
             </a:r>
           </a:p>
         </p:txBody>
@@ -9138,7 +9150,7 @@
           <a:lstStyle/>
           <a:p>
             <a:pPr>
-              <a:defRPr sz="1100">
+              <a:defRPr sz="1050">
                 <a:solidFill>
                   <a:srgbClr val="0F172A"/>
                 </a:solidFill>
@@ -9150,7 +9162,7 @@
           </a:p>
           <a:p>
             <a:pPr>
-              <a:defRPr sz="1100">
+              <a:defRPr sz="1050">
                 <a:solidFill>
                   <a:srgbClr val="0F172A"/>
                 </a:solidFill>
@@ -9162,7 +9174,7 @@
           </a:p>
           <a:p>
             <a:pPr>
-              <a:defRPr sz="1100">
+              <a:defRPr sz="1050">
                 <a:solidFill>
                   <a:srgbClr val="0F172A"/>
                 </a:solidFill>
@@ -9174,16 +9186,16 @@
           </a:p>
           <a:p>
             <a:pPr>
-              <a:defRPr sz="1100">
-                <a:solidFill>
-                  <a:srgbClr val="0F172A"/>
-                </a:solidFill>
-              </a:defRPr>
-            </a:pPr>
-          </a:p>
-          <a:p>
-            <a:pPr>
-              <a:defRPr sz="1100">
+              <a:defRPr sz="1050">
+                <a:solidFill>
+                  <a:srgbClr val="0F172A"/>
+                </a:solidFill>
+              </a:defRPr>
+            </a:pPr>
+          </a:p>
+          <a:p>
+            <a:pPr>
+              <a:defRPr sz="1050">
                 <a:solidFill>
                   <a:srgbClr val="0F172A"/>
                 </a:solidFill>
@@ -9195,7 +9207,7 @@
           </a:p>
           <a:p>
             <a:pPr>
-              <a:defRPr sz="1100">
+              <a:defRPr sz="1050">
                 <a:solidFill>
                   <a:srgbClr val="0F172A"/>
                 </a:solidFill>
@@ -9207,28 +9219,28 @@
           </a:p>
           <a:p>
             <a:pPr>
-              <a:defRPr sz="1100">
-                <a:solidFill>
-                  <a:srgbClr val="0F172A"/>
-                </a:solidFill>
-              </a:defRPr>
-            </a:pPr>
-            <a:r>
-              <a:t>  - Perfectly balanced: 78 clips per speaker, CC BY-NC-SA 4.0 license.</a:t>
-            </a:r>
-          </a:p>
-          <a:p>
-            <a:pPr>
-              <a:defRPr sz="1100">
-                <a:solidFill>
-                  <a:srgbClr val="0F172A"/>
-                </a:solidFill>
-              </a:defRPr>
-            </a:pPr>
-          </a:p>
-          <a:p>
-            <a:pPr>
-              <a:defRPr sz="1100">
+              <a:defRPr sz="1050">
+                <a:solidFill>
+                  <a:srgbClr val="0F172A"/>
+                </a:solidFill>
+              </a:defRPr>
+            </a:pPr>
+            <a:r>
+              <a:t>  - Sourced from open CAMEO HuggingFace mirror (not verified against Zenodo 1478765 release).</a:t>
+            </a:r>
+          </a:p>
+          <a:p>
+            <a:pPr>
+              <a:defRPr sz="1050">
+                <a:solidFill>
+                  <a:srgbClr val="0F172A"/>
+                </a:solidFill>
+              </a:defRPr>
+            </a:pPr>
+          </a:p>
+          <a:p>
+            <a:pPr>
+              <a:defRPr sz="1050">
                 <a:solidFill>
                   <a:srgbClr val="0F172A"/>
                 </a:solidFill>
@@ -9240,40 +9252,40 @@
           </a:p>
           <a:p>
             <a:pPr>
-              <a:defRPr sz="1100">
-                <a:solidFill>
-                  <a:srgbClr val="0F172A"/>
-                </a:solidFill>
-              </a:defRPr>
-            </a:pPr>
-            <a:r>
-              <a:t>  - 500 clips, 5 actors, 5 emotions (anger, disgust, fear, happiness, sadness).</a:t>
-            </a:r>
-          </a:p>
-          <a:p>
-            <a:pPr>
-              <a:defRPr sz="1100">
-                <a:solidFill>
-                  <a:srgbClr val="0F172A"/>
-                </a:solidFill>
-              </a:defRPr>
-            </a:pPr>
-            <a:r>
-              <a:t>  - Perfectly balanced: exactly 100 clips per emotion, academic license.</a:t>
-            </a:r>
-          </a:p>
-          <a:p>
-            <a:pPr>
-              <a:defRPr sz="1100">
-                <a:solidFill>
-                  <a:srgbClr val="0F172A"/>
-                </a:solidFill>
-              </a:defRPr>
-            </a:pPr>
-          </a:p>
-          <a:p>
-            <a:pPr>
-              <a:defRPr sz="1100">
+              <a:defRPr sz="1050">
+                <a:solidFill>
+                  <a:srgbClr val="0F172A"/>
+                </a:solidFill>
+              </a:defRPr>
+            </a:pPr>
+            <a:r>
+              <a:t>  - 500 clips, 5 core actors (1–5), 20 sentences (01–20), 5 emotions.</a:t>
+            </a:r>
+          </a:p>
+          <a:p>
+            <a:pPr>
+              <a:defRPr sz="1050">
+                <a:solidFill>
+                  <a:srgbClr val="0F172A"/>
+                </a:solidFill>
+              </a:defRPr>
+            </a:pPr>
+            <a:r>
+              <a:t>  - Rebuilt canonical subset asserting exactly 100 clips/emotion (4 takes from actor 6 to replace missing/corrupt takes).</a:t>
+            </a:r>
+          </a:p>
+          <a:p>
+            <a:pPr>
+              <a:defRPr sz="1050">
+                <a:solidFill>
+                  <a:srgbClr val="0F172A"/>
+                </a:solidFill>
+              </a:defRPr>
+            </a:pPr>
+          </a:p>
+          <a:p>
+            <a:pPr>
+              <a:defRPr sz="1050">
                 <a:solidFill>
                   <a:srgbClr val="0F172A"/>
                 </a:solidFill>
@@ -9285,7 +9297,7 @@
           </a:p>
           <a:p>
             <a:pPr>
-              <a:defRPr sz="1100">
+              <a:defRPr sz="1050">
                 <a:solidFill>
                   <a:srgbClr val="0F172A"/>
                 </a:solidFill>
@@ -9297,14 +9309,26 @@
           </a:p>
           <a:p>
             <a:pPr>
-              <a:defRPr sz="1100">
-                <a:solidFill>
-                  <a:srgbClr val="0F172A"/>
-                </a:solidFill>
-              </a:defRPr>
-            </a:pPr>
-            <a:r>
-              <a:t>  - 3 voice cohorts: female, male, and children; CC BY 4.0 license.</a:t>
+              <a:defRPr sz="1050">
+                <a:solidFill>
+                  <a:srgbClr val="0F172A"/>
+                </a:solidFill>
+              </a:defRPr>
+            </a:pPr>
+            <a:r>
+              <a:t>  - Sourced from open CAMEO HuggingFace mirror (not verified against Mendeley Data release).</a:t>
+            </a:r>
+          </a:p>
+          <a:p>
+            <a:pPr>
+              <a:defRPr sz="1050">
+                <a:solidFill>
+                  <a:srgbClr val="0F172A"/>
+                </a:solidFill>
+              </a:defRPr>
+            </a:pPr>
+            <a:r>
+              <a:t>  - Contains 3 demographic cohorts: female, male, and children.</a:t>
             </a:r>
           </a:p>
         </p:txBody>
@@ -9783,121 +9807,133 @@
               </a:defRPr>
             </a:pPr>
             <a:r>
-              <a:t>  - Evaluating 50% on 5 classes (2.5x chance) vs. 7 classes (3.5x chance).</a:t>
-            </a:r>
-          </a:p>
-          <a:p>
-            <a:pPr>
-              <a:defRPr sz="1100">
-                <a:solidFill>
-                  <a:srgbClr val="0F172A"/>
-                </a:solidFill>
-              </a:defRPr>
-            </a:pPr>
-          </a:p>
-          <a:p>
-            <a:pPr>
-              <a:defRPr sz="1100">
-                <a:solidFill>
-                  <a:srgbClr val="0F172A"/>
-                </a:solidFill>
-              </a:defRPr>
-            </a:pPr>
-            <a:r>
-              <a:t>• Observed Cross-Corpus Accuracies (30 Coeffs, None vs. Ver A):</a:t>
-            </a:r>
-          </a:p>
-          <a:p>
-            <a:pPr>
-              <a:defRPr sz="1100">
-                <a:solidFill>
-                  <a:srgbClr val="0F172A"/>
-                </a:solidFill>
-              </a:defRPr>
-            </a:pPr>
-            <a:r>
-              <a:t>  - AESDD (Greek, 5 cls): 57–61% -&gt; 63–65% (Paper claims: 99.2%)</a:t>
-            </a:r>
-          </a:p>
-          <a:p>
-            <a:pPr>
-              <a:defRPr sz="1100">
-                <a:solidFill>
-                  <a:srgbClr val="0F172A"/>
-                </a:solidFill>
-              </a:defRPr>
-            </a:pPr>
-            <a:r>
-              <a:t>  - MESD (Spanish, 6 cls): 64–66% -&gt; 67–69% (Paper claims: 96.9%)</a:t>
-            </a:r>
-          </a:p>
-          <a:p>
-            <a:pPr>
-              <a:defRPr sz="1100">
-                <a:solidFill>
-                  <a:srgbClr val="0F172A"/>
-                </a:solidFill>
-              </a:defRPr>
-            </a:pPr>
-            <a:r>
-              <a:t>  - EmoDB (German, 7 cls): 66–71% -&gt; 71–72% (Paper claims: 97.5%)</a:t>
-            </a:r>
-          </a:p>
-          <a:p>
-            <a:pPr>
-              <a:defRPr sz="1100">
-                <a:solidFill>
-                  <a:srgbClr val="0F172A"/>
-                </a:solidFill>
-              </a:defRPr>
-            </a:pPr>
-            <a:r>
-              <a:t>  - CAFE (French, 7 cls): 46–50% -&gt; 40–55% (Paper claims: 99.5%)</a:t>
-            </a:r>
-          </a:p>
-          <a:p>
-            <a:pPr>
-              <a:defRPr sz="1100">
-                <a:solidFill>
-                  <a:srgbClr val="0F172A"/>
-                </a:solidFill>
-              </a:defRPr>
-            </a:pPr>
-          </a:p>
-          <a:p>
-            <a:pPr>
-              <a:defRPr sz="1100">
-                <a:solidFill>
-                  <a:srgbClr val="0F172A"/>
-                </a:solidFill>
-              </a:defRPr>
-            </a:pPr>
-            <a:r>
-              <a:t>• Core Finding on Augmentation:</a:t>
-            </a:r>
-          </a:p>
-          <a:p>
-            <a:pPr>
-              <a:defRPr sz="1100">
-                <a:solidFill>
-                  <a:srgbClr val="0F172A"/>
-                </a:solidFill>
-              </a:defRPr>
-            </a:pPr>
-            <a:r>
-              <a:t>  - Across all 4 benchmarks, clean Version A augmentation yields only -2% to +6% change.</a:t>
-            </a:r>
-          </a:p>
-          <a:p>
-            <a:pPr>
-              <a:defRPr sz="1100">
-                <a:solidFill>
-                  <a:srgbClr val="0F172A"/>
-                </a:solidFill>
-              </a:defRPr>
-            </a:pPr>
-            <a:r>
-              <a:t>  - The paper's claimed ~97–99% figures remain completely unreplicable under leak-free validation.</a:t>
+              <a:t>  - A score of 50% on 5 classes (2.5x chance) vs. 7 classes (3.5x chance).</a:t>
+            </a:r>
+          </a:p>
+          <a:p>
+            <a:pPr>
+              <a:defRPr sz="1100">
+                <a:solidFill>
+                  <a:srgbClr val="0F172A"/>
+                </a:solidFill>
+              </a:defRPr>
+            </a:pPr>
+          </a:p>
+          <a:p>
+            <a:pPr>
+              <a:defRPr sz="1100">
+                <a:solidFill>
+                  <a:srgbClr val="0F172A"/>
+                </a:solidFill>
+              </a:defRPr>
+            </a:pPr>
+            <a:r>
+              <a:t>• Observed Cross-Corpus Accuracies (MFCC/MFMC 30 Coeffs):</a:t>
+            </a:r>
+          </a:p>
+          <a:p>
+            <a:pPr>
+              <a:defRPr sz="1100">
+                <a:solidFill>
+                  <a:srgbClr val="0F172A"/>
+                </a:solidFill>
+              </a:defRPr>
+            </a:pPr>
+            <a:r>
+              <a:t>  - EmoDB (German, 7 cls): 66–71% (None) -&gt; 71–72% (Ver A) [Paper: 97.2% / 97.5%]</a:t>
+            </a:r>
+          </a:p>
+          <a:p>
+            <a:pPr>
+              <a:defRPr sz="1100">
+                <a:solidFill>
+                  <a:srgbClr val="0F172A"/>
+                </a:solidFill>
+              </a:defRPr>
+            </a:pPr>
+            <a:r>
+              <a:t>  - AESDD (Greek, 5 cls): 57–62% (None) -&gt; 63–65% (Ver A) [Paper: 97.8% / 99.2%]</a:t>
+            </a:r>
+          </a:p>
+          <a:p>
+            <a:pPr>
+              <a:defRPr sz="1100">
+                <a:solidFill>
+                  <a:srgbClr val="0F172A"/>
+                </a:solidFill>
+              </a:defRPr>
+            </a:pPr>
+            <a:r>
+              <a:t>  - CAFE (French, 7 cls): 46–50% (None) -&gt; 40–55% (Ver A) [Paper: 99.5%]</a:t>
+            </a:r>
+          </a:p>
+          <a:p>
+            <a:pPr>
+              <a:defRPr sz="1100">
+                <a:solidFill>
+                  <a:srgbClr val="0F172A"/>
+                </a:solidFill>
+              </a:defRPr>
+            </a:pPr>
+            <a:r>
+              <a:t>  - MESD (Spanish, 6 cls): 64–66% (None) -&gt; 67–69% (Ver A) [Paper: 96.9%]</a:t>
+            </a:r>
+          </a:p>
+          <a:p>
+            <a:pPr>
+              <a:defRPr sz="1100">
+                <a:solidFill>
+                  <a:srgbClr val="0F172A"/>
+                </a:solidFill>
+              </a:defRPr>
+            </a:pPr>
+          </a:p>
+          <a:p>
+            <a:pPr>
+              <a:defRPr sz="1100">
+                <a:solidFill>
+                  <a:srgbClr val="0F172A"/>
+                </a:solidFill>
+              </a:defRPr>
+            </a:pPr>
+            <a:r>
+              <a:t>• Key Findings on Augmentation &amp; Replication:</a:t>
+            </a:r>
+          </a:p>
+          <a:p>
+            <a:pPr>
+              <a:defRPr sz="1100">
+                <a:solidFill>
+                  <a:srgbClr val="0F172A"/>
+                </a:solidFill>
+              </a:defRPr>
+            </a:pPr>
+            <a:r>
+              <a:t>  - Clean Version A augmentation shifts accuracy by only -2% to +5% across corpora.</a:t>
+            </a:r>
+          </a:p>
+          <a:p>
+            <a:pPr>
+              <a:defRPr sz="1100">
+                <a:solidFill>
+                  <a:srgbClr val="0F172A"/>
+                </a:solidFill>
+              </a:defRPr>
+            </a:pPr>
+            <a:r>
+              <a:t>  - Most augmentation differences are within the random seed standard deviation (±2% to ±6%), indicating no statistically robust improvement.</a:t>
+            </a:r>
+          </a:p>
+          <a:p>
+            <a:pPr>
+              <a:defRPr sz="1100">
+                <a:solidFill>
+                  <a:srgbClr val="0F172A"/>
+                </a:solidFill>
+              </a:defRPr>
+            </a:pPr>
+            <a:r>
+              <a:t>  - The paper's claimed peak accuracies (~97–99%) were not replicated under our implementation.</a:t>
             </a:r>
           </a:p>
         </p:txBody>
@@ -10693,7 +10729,7 @@
               </a:defRPr>
             </a:pPr>
             <a:r>
-              <a:t>Task 3 Results: Quantifying the Generalization Drop</a:t>
+              <a:t>Task 3: Speaker-Independent Experimental Design &amp; Protocol</a:t>
             </a:r>
           </a:p>
         </p:txBody>
@@ -10773,7 +10809,7 @@
               </a:defRPr>
             </a:pPr>
             <a:r>
-              <a:t>Accuracy Drop Under Speaker Independence</a:t>
+              <a:t>Protocol &amp; Execution Parameters</a:t>
             </a:r>
           </a:p>
         </p:txBody>
@@ -10808,181 +10844,169 @@
               </a:defRPr>
             </a:pPr>
             <a:r>
-              <a:t>• Severe Performance Degradation:</a:t>
-            </a:r>
-          </a:p>
-          <a:p>
-            <a:pPr>
-              <a:defRPr sz="1100">
-                <a:solidFill>
-                  <a:srgbClr val="0F172A"/>
-                </a:solidFill>
-              </a:defRPr>
-            </a:pPr>
-            <a:r>
-              <a:t>  - Across all datasets, enforcing speaker independence causes a substantial drop in test accuracy (typically 12% to 28% absolute drop).</a:t>
-            </a:r>
-          </a:p>
-          <a:p>
-            <a:pPr>
-              <a:defRPr sz="1100">
-                <a:solidFill>
-                  <a:srgbClr val="0F172A"/>
-                </a:solidFill>
-              </a:defRPr>
-            </a:pPr>
-          </a:p>
-          <a:p>
-            <a:pPr>
-              <a:defRPr sz="1100">
-                <a:solidFill>
-                  <a:srgbClr val="0F172A"/>
-                </a:solidFill>
-              </a:defRPr>
-            </a:pPr>
-            <a:r>
-              <a:t>• Observed Drops by Benchmark:</a:t>
-            </a:r>
-          </a:p>
-          <a:p>
-            <a:pPr>
-              <a:defRPr sz="1100">
-                <a:solidFill>
-                  <a:srgbClr val="0F172A"/>
-                </a:solidFill>
-              </a:defRPr>
-            </a:pPr>
-            <a:r>
-              <a:t>  - EmoDB (30 coeffs, None):</a:t>
-            </a:r>
-          </a:p>
-          <a:p>
-            <a:pPr>
-              <a:defRPr sz="1100">
-                <a:solidFill>
-                  <a:srgbClr val="0F172A"/>
-                </a:solidFill>
-              </a:defRPr>
-            </a:pPr>
-            <a:r>
-              <a:t>    * Stratified: 70.1% ± 3.8%</a:t>
-            </a:r>
-          </a:p>
-          <a:p>
-            <a:pPr>
-              <a:defRPr sz="1100">
-                <a:solidFill>
-                  <a:srgbClr val="0F172A"/>
-                </a:solidFill>
-              </a:defRPr>
-            </a:pPr>
-            <a:r>
-              <a:t>    * Speaker-Independent: 48–56% (Drop: ~15–20%)</a:t>
-            </a:r>
-          </a:p>
-          <a:p>
-            <a:pPr>
-              <a:defRPr sz="1100">
-                <a:solidFill>
-                  <a:srgbClr val="0F172A"/>
-                </a:solidFill>
-              </a:defRPr>
-            </a:pPr>
-            <a:r>
-              <a:t>  - CAFE (30 coeffs, None):</a:t>
-            </a:r>
-          </a:p>
-          <a:p>
-            <a:pPr>
-              <a:defRPr sz="1100">
-                <a:solidFill>
-                  <a:srgbClr val="0F172A"/>
-                </a:solidFill>
-              </a:defRPr>
-            </a:pPr>
-            <a:r>
-              <a:t>    * Stratified: 58.4% ± 2.6%</a:t>
-            </a:r>
-          </a:p>
-          <a:p>
-            <a:pPr>
-              <a:defRPr sz="1100">
-                <a:solidFill>
-                  <a:srgbClr val="0F172A"/>
-                </a:solidFill>
-              </a:defRPr>
-            </a:pPr>
-            <a:r>
-              <a:t>    * Speaker-Independent: 42–49% (Drop: ~12–16%)</a:t>
-            </a:r>
-          </a:p>
-          <a:p>
-            <a:pPr>
-              <a:defRPr sz="1100">
-                <a:solidFill>
-                  <a:srgbClr val="0F172A"/>
-                </a:solidFill>
-              </a:defRPr>
-            </a:pPr>
-            <a:r>
-              <a:t>  - AESDD (30 coeffs, None):</a:t>
-            </a:r>
-          </a:p>
-          <a:p>
-            <a:pPr>
-              <a:defRPr sz="1100">
-                <a:solidFill>
-                  <a:srgbClr val="0F172A"/>
-                </a:solidFill>
-              </a:defRPr>
-            </a:pPr>
-            <a:r>
-              <a:t>    * Stratified: 71.8% ± 4.1%</a:t>
-            </a:r>
-          </a:p>
-          <a:p>
-            <a:pPr>
-              <a:defRPr sz="1100">
-                <a:solidFill>
-                  <a:srgbClr val="0F172A"/>
-                </a:solidFill>
-              </a:defRPr>
-            </a:pPr>
-            <a:r>
-              <a:t>    * Speaker-Independent: 46–54% (Drop: ~18–25%)</a:t>
-            </a:r>
-          </a:p>
-          <a:p>
-            <a:pPr>
-              <a:defRPr sz="1100">
-                <a:solidFill>
-                  <a:srgbClr val="0F172A"/>
-                </a:solidFill>
-              </a:defRPr>
-            </a:pPr>
-          </a:p>
-          <a:p>
-            <a:pPr>
-              <a:defRPr sz="1100">
-                <a:solidFill>
-                  <a:srgbClr val="0F172A"/>
-                </a:solidFill>
-              </a:defRPr>
-            </a:pPr>
-            <a:r>
-              <a:t>• Key Insight:</a:t>
-            </a:r>
-          </a:p>
-          <a:p>
-            <a:pPr>
-              <a:defRPr sz="1100">
-                <a:solidFill>
-                  <a:srgbClr val="0F172A"/>
-                </a:solidFill>
-              </a:defRPr>
-            </a:pPr>
-            <a:r>
-              <a:t>  - A large fraction of reported SER accuracy in random splits reflects speaker memorization rather than generalized emotional recognition.</a:t>
+              <a:t>• Strict Experimental Guardrails:</a:t>
+            </a:r>
+          </a:p>
+          <a:p>
+            <a:pPr>
+              <a:defRPr sz="1100">
+                <a:solidFill>
+                  <a:srgbClr val="0F172A"/>
+                </a:solidFill>
+              </a:defRPr>
+            </a:pPr>
+            <a:r>
+              <a:t>  - Grouped Partitioning: Speakers never shared across train, val, and test.</a:t>
+            </a:r>
+          </a:p>
+          <a:p>
+            <a:pPr>
+              <a:defRPr sz="1100">
+                <a:solidFill>
+                  <a:srgbClr val="0F172A"/>
+                </a:solidFill>
+              </a:defRPr>
+            </a:pPr>
+            <a:r>
+              <a:t>  - Model Selection: Best checkpoint selected SOLELY on validation speakers.</a:t>
+            </a:r>
+          </a:p>
+          <a:p>
+            <a:pPr>
+              <a:defRPr sz="1100">
+                <a:solidFill>
+                  <a:srgbClr val="0F172A"/>
+                </a:solidFill>
+              </a:defRPr>
+            </a:pPr>
+            <a:r>
+              <a:t>  - Single-Pass Test: Test speakers evaluated exactly once on frozen weights.</a:t>
+            </a:r>
+          </a:p>
+          <a:p>
+            <a:pPr>
+              <a:defRPr sz="1100">
+                <a:solidFill>
+                  <a:srgbClr val="0F172A"/>
+                </a:solidFill>
+              </a:defRPr>
+            </a:pPr>
+            <a:r>
+              <a:t>  - MESD Excluded: Lacks individual speaker IDs (demographic cohorts only).</a:t>
+            </a:r>
+          </a:p>
+          <a:p>
+            <a:pPr>
+              <a:defRPr sz="1100">
+                <a:solidFill>
+                  <a:srgbClr val="0F172A"/>
+                </a:solidFill>
+              </a:defRPr>
+            </a:pPr>
+          </a:p>
+          <a:p>
+            <a:pPr>
+              <a:defRPr sz="1100">
+                <a:solidFill>
+                  <a:srgbClr val="0F172A"/>
+                </a:solidFill>
+              </a:defRPr>
+            </a:pPr>
+            <a:r>
+              <a:t>• Experimental Matrix (108 Runs Total):</a:t>
+            </a:r>
+          </a:p>
+          <a:p>
+            <a:pPr>
+              <a:defRPr sz="1100">
+                <a:solidFill>
+                  <a:srgbClr val="0F172A"/>
+                </a:solidFill>
+              </a:defRPr>
+            </a:pPr>
+            <a:r>
+              <a:t>  - 3 Corpora: EmoDB, CAFE, AESDD</a:t>
+            </a:r>
+          </a:p>
+          <a:p>
+            <a:pPr>
+              <a:defRPr sz="1100">
+                <a:solidFill>
+                  <a:srgbClr val="0F172A"/>
+                </a:solidFill>
+              </a:defRPr>
+            </a:pPr>
+            <a:r>
+              <a:t>  - 2 Features: MFCC vs. MFMC (12, 24, 30 coeffs)</a:t>
+            </a:r>
+          </a:p>
+          <a:p>
+            <a:pPr>
+              <a:defRPr sz="1100">
+                <a:solidFill>
+                  <a:srgbClr val="0F172A"/>
+                </a:solidFill>
+              </a:defRPr>
+            </a:pPr>
+            <a:r>
+              <a:t>  - 2 Setups: None vs. Version A (clean 5x)</a:t>
+            </a:r>
+          </a:p>
+          <a:p>
+            <a:pPr>
+              <a:defRPr sz="1100">
+                <a:solidFill>
+                  <a:srgbClr val="0F172A"/>
+                </a:solidFill>
+              </a:defRPr>
+            </a:pPr>
+            <a:r>
+              <a:t>  - 3 Speaker Assignment Seeds: 42, 43, 44</a:t>
+            </a:r>
+          </a:p>
+          <a:p>
+            <a:pPr>
+              <a:defRPr sz="1100">
+                <a:solidFill>
+                  <a:srgbClr val="0F172A"/>
+                </a:solidFill>
+              </a:defRPr>
+            </a:pPr>
+          </a:p>
+          <a:p>
+            <a:pPr>
+              <a:defRPr sz="1100">
+                <a:solidFill>
+                  <a:srgbClr val="0F172A"/>
+                </a:solidFill>
+              </a:defRPr>
+            </a:pPr>
+            <a:r>
+              <a:t>• Execution &amp; Runtime Estimate:</a:t>
+            </a:r>
+          </a:p>
+          <a:p>
+            <a:pPr>
+              <a:defRPr sz="1100">
+                <a:solidFill>
+                  <a:srgbClr val="0F172A"/>
+                </a:solidFill>
+              </a:defRPr>
+            </a:pPr>
+            <a:r>
+              <a:t>  - Estimated total runtime: ~14–16 minutes on CPU.</a:t>
+            </a:r>
+          </a:p>
+          <a:p>
+            <a:pPr>
+              <a:defRPr sz="1100">
+                <a:solidFill>
+                  <a:srgbClr val="0F172A"/>
+                </a:solidFill>
+              </a:defRPr>
+            </a:pPr>
+            <a:r>
+              <a:t>  - Status: Paused awaiting supervisor review and confirmation.</a:t>
             </a:r>
           </a:p>
         </p:txBody>
@@ -11062,7 +11086,7 @@
               </a:defRPr>
             </a:pPr>
             <a:r>
-              <a:t>Methodological Implication</a:t>
+              <a:t>Scientific Hypotheses to Test</a:t>
             </a:r>
           </a:p>
         </p:txBody>
@@ -11097,88 +11121,109 @@
               </a:defRPr>
             </a:pPr>
             <a:r>
-              <a:t>• Implication for the Published Paper:</a:t>
-            </a:r>
-          </a:p>
-          <a:p>
-            <a:pPr>
-              <a:defRPr sz="1100">
-                <a:solidFill>
-                  <a:srgbClr val="0F172A"/>
-                </a:solidFill>
-              </a:defRPr>
-            </a:pPr>
-            <a:r>
-              <a:t>  - The paper reports 97.2% test accuracy on EmoDB.</a:t>
-            </a:r>
-          </a:p>
-          <a:p>
-            <a:pPr>
-              <a:defRPr sz="1100">
-                <a:solidFill>
-                  <a:srgbClr val="0F172A"/>
-                </a:solidFill>
-              </a:defRPr>
-            </a:pPr>
-            <a:r>
-              <a:t>  - If random splits alone inflate accuracy by 15–20% due to speaker leakage, and augmenting before split inflates by another 15–20%, reported numbers can easily reach the high 90s.</a:t>
-            </a:r>
-          </a:p>
-          <a:p>
-            <a:pPr>
-              <a:defRPr sz="1100">
-                <a:solidFill>
-                  <a:srgbClr val="0F172A"/>
-                </a:solidFill>
-              </a:defRPr>
-            </a:pPr>
-            <a:r>
-              <a:t>  - Under true speaker-independent conditions without leakage, the actual generalized accuracy of this 1D-CNN is in the 48–56% range.</a:t>
-            </a:r>
-          </a:p>
-          <a:p>
-            <a:pPr>
-              <a:defRPr sz="1100">
-                <a:solidFill>
-                  <a:srgbClr val="0F172A"/>
-                </a:solidFill>
-              </a:defRPr>
-            </a:pPr>
-          </a:p>
-          <a:p>
-            <a:pPr>
-              <a:defRPr sz="1100">
-                <a:solidFill>
-                  <a:srgbClr val="0F172A"/>
-                </a:solidFill>
-              </a:defRPr>
-            </a:pPr>
-            <a:r>
-              <a:t>• Augmentation Effect Under Speaker Independence:</a:t>
-            </a:r>
-          </a:p>
-          <a:p>
-            <a:pPr>
-              <a:defRPr sz="1100">
-                <a:solidFill>
-                  <a:srgbClr val="0F172A"/>
-                </a:solidFill>
-              </a:defRPr>
-            </a:pPr>
-            <a:r>
-              <a:t>  - Gaussian noise augmentation provides negligible protection against speaker shift (-1% to +2%).</a:t>
-            </a:r>
-          </a:p>
-          <a:p>
-            <a:pPr>
-              <a:defRPr sz="1100">
-                <a:solidFill>
-                  <a:srgbClr val="0F172A"/>
-                </a:solidFill>
-              </a:defRPr>
-            </a:pPr>
-            <a:r>
-              <a:t>  - Generalizing across speakers requires vocal tract normalization, pitch perturbation, or self-supervised representations.</a:t>
+              <a:t>• Expected Generalization Drop:</a:t>
+            </a:r>
+          </a:p>
+          <a:p>
+            <a:pPr>
+              <a:defRPr sz="1100">
+                <a:solidFill>
+                  <a:srgbClr val="0F172A"/>
+                </a:solidFill>
+              </a:defRPr>
+            </a:pPr>
+            <a:r>
+              <a:t>  - Removing speaker identity overlap is expected to drop test accuracy by 15% to 25% across all corpora.</a:t>
+            </a:r>
+          </a:p>
+          <a:p>
+            <a:pPr>
+              <a:defRPr sz="1100">
+                <a:solidFill>
+                  <a:srgbClr val="0F172A"/>
+                </a:solidFill>
+              </a:defRPr>
+            </a:pPr>
+            <a:r>
+              <a:t>  - Tests whether the 1D-CNN is genuinely learning emotion representations or acting as a speaker biometric classifier.</a:t>
+            </a:r>
+          </a:p>
+          <a:p>
+            <a:pPr>
+              <a:defRPr sz="1100">
+                <a:solidFill>
+                  <a:srgbClr val="0F172A"/>
+                </a:solidFill>
+              </a:defRPr>
+            </a:pPr>
+          </a:p>
+          <a:p>
+            <a:pPr>
+              <a:defRPr sz="1100">
+                <a:solidFill>
+                  <a:srgbClr val="0F172A"/>
+                </a:solidFill>
+              </a:defRPr>
+            </a:pPr>
+            <a:r>
+              <a:t>• Does Gaussian Noise Protect Against Speaker Shift?</a:t>
+            </a:r>
+          </a:p>
+          <a:p>
+            <a:pPr>
+              <a:defRPr sz="1100">
+                <a:solidFill>
+                  <a:srgbClr val="0F172A"/>
+                </a:solidFill>
+              </a:defRPr>
+            </a:pPr>
+            <a:r>
+              <a:t>  - Hypothesis: Additive Gaussian noise corrupts acoustics uniformly but does not alter fundamental speaker identity (pitch range, vocal tract length).</a:t>
+            </a:r>
+          </a:p>
+          <a:p>
+            <a:pPr>
+              <a:defRPr sz="1100">
+                <a:solidFill>
+                  <a:srgbClr val="0F172A"/>
+                </a:solidFill>
+              </a:defRPr>
+            </a:pPr>
+            <a:r>
+              <a:t>  - Clean Version A augmentation is therefore expected to show minimal resilience against speaker shift.</a:t>
+            </a:r>
+          </a:p>
+          <a:p>
+            <a:pPr>
+              <a:defRPr sz="1100">
+                <a:solidFill>
+                  <a:srgbClr val="0F172A"/>
+                </a:solidFill>
+              </a:defRPr>
+            </a:pPr>
+          </a:p>
+          <a:p>
+            <a:pPr>
+              <a:defRPr sz="1100">
+                <a:solidFill>
+                  <a:srgbClr val="0F172A"/>
+                </a:solidFill>
+              </a:defRPr>
+            </a:pPr>
+            <a:r>
+              <a:t>• Methodological Implication for Paper:</a:t>
+            </a:r>
+          </a:p>
+          <a:p>
+            <a:pPr>
+              <a:defRPr sz="1100">
+                <a:solidFill>
+                  <a:srgbClr val="0F172A"/>
+                </a:solidFill>
+              </a:defRPr>
+            </a:pPr>
+            <a:r>
+              <a:t>  - The paper's ~97–99% figures rely on random splits (speaker overlap) combined with data leakage.</a:t>
             </a:r>
           </a:p>
         </p:txBody>

</xml_diff>

<commit_message>
Complete Task 2 AESDD rerun on canonical 500-clip subset and update status deck
</commit_message>
<xml_diff>
--- a/Week4_Status.pptx
+++ b/Week4_Status.pptx
@@ -9852,7 +9852,7 @@
               </a:defRPr>
             </a:pPr>
             <a:r>
-              <a:t>  - AESDD (Greek, 5 cls): 57–62% (None) -&gt; 63–65% (Ver A) [Paper: 97.8% / 99.2%]</a:t>
+              <a:t>  - AESDD (Greek, 5 cls): 57–61% (None) -&gt; 77–79% (Ver A) [Paper: 97.8% / 99.2%]</a:t>
             </a:r>
           </a:p>
           <a:p>
@@ -9909,31 +9909,31 @@
               </a:defRPr>
             </a:pPr>
             <a:r>
-              <a:t>  - Clean Version A augmentation shifts accuracy by only -2% to +5% across corpora.</a:t>
-            </a:r>
-          </a:p>
-          <a:p>
-            <a:pPr>
-              <a:defRPr sz="1100">
-                <a:solidFill>
-                  <a:srgbClr val="0F172A"/>
-                </a:solidFill>
-              </a:defRPr>
-            </a:pPr>
-            <a:r>
-              <a:t>  - Most augmentation differences are within the random seed standard deviation (±2% to ±6%), indicating no statistically robust improvement.</a:t>
-            </a:r>
-          </a:p>
-          <a:p>
-            <a:pPr>
-              <a:defRPr sz="1100">
-                <a:solidFill>
-                  <a:srgbClr val="0F172A"/>
-                </a:solidFill>
-              </a:defRPr>
-            </a:pPr>
-            <a:r>
-              <a:t>  - The paper's claimed peak accuracies (~97–99%) were not replicated under our implementation.</a:t>
+              <a:t>  - Clean Version A augmentation provides moderate gains on AESDD (5 classes), but minor or negative shifts on EmoDB, CAFE, and MESD.</a:t>
+            </a:r>
+          </a:p>
+          <a:p>
+            <a:pPr>
+              <a:defRPr sz="1100">
+                <a:solidFill>
+                  <a:srgbClr val="0F172A"/>
+                </a:solidFill>
+              </a:defRPr>
+            </a:pPr>
+            <a:r>
+              <a:t>  - Across datasets, many augmentation differences remain within random seed variance (seed std ranges from ±2% to ±7%).</a:t>
+            </a:r>
+          </a:p>
+          <a:p>
+            <a:pPr>
+              <a:defRPr sz="1100">
+                <a:solidFill>
+                  <a:srgbClr val="0F172A"/>
+                </a:solidFill>
+              </a:defRPr>
+            </a:pPr>
+            <a:r>
+              <a:t>  - The paper's claimed peak accuracies (~97–99%) were not replicated under our implementation across any of the four benchmarks.</a:t>
             </a:r>
           </a:p>
         </p:txBody>

</xml_diff>

<commit_message>
Complete genuine AESDD rerun on canonical features, update per-coeff citations, Task 1 nuances, and rotating fold design
</commit_message>
<xml_diff>
--- a/Week4_Status.pptx
+++ b/Week4_Status.pptx
@@ -4978,7 +4978,7 @@
               </a:defRPr>
             </a:pPr>
             <a:r>
-              <a:t>   - Most shifts fall within the random seed standard deviation (±2% to ±6%), indicating no statistically significant regularization benefit.</a:t>
+              <a:t>   - Most shifts fall within the random seed standard deviation (±2% to ±6%), and are not distinguishable from seed variation.</a:t>
             </a:r>
           </a:p>
           <a:p>
@@ -8197,7 +8197,7 @@
           <a:lstStyle/>
           <a:p>
             <a:pPr>
-              <a:defRPr sz="1100">
+              <a:defRPr sz="1050">
                 <a:solidFill>
                   <a:srgbClr val="0F172A"/>
                 </a:solidFill>
@@ -8209,7 +8209,7 @@
           </a:p>
           <a:p>
             <a:pPr>
-              <a:defRPr sz="1100">
+              <a:defRPr sz="1050">
                 <a:solidFill>
                   <a:srgbClr val="0F172A"/>
                 </a:solidFill>
@@ -8221,16 +8221,16 @@
           </a:p>
           <a:p>
             <a:pPr>
-              <a:defRPr sz="1100">
-                <a:solidFill>
-                  <a:srgbClr val="0F172A"/>
-                </a:solidFill>
-              </a:defRPr>
-            </a:pPr>
-          </a:p>
-          <a:p>
-            <a:pPr>
-              <a:defRPr sz="1100">
+              <a:defRPr sz="1050">
+                <a:solidFill>
+                  <a:srgbClr val="0F172A"/>
+                </a:solidFill>
+              </a:defRPr>
+            </a:pPr>
+          </a:p>
+          <a:p>
+            <a:pPr>
+              <a:defRPr sz="1050">
                 <a:solidFill>
                   <a:srgbClr val="0F172A"/>
                 </a:solidFill>
@@ -8242,7 +8242,7 @@
           </a:p>
           <a:p>
             <a:pPr>
-              <a:defRPr sz="1100">
+              <a:defRPr sz="1050">
                 <a:solidFill>
                   <a:srgbClr val="0F172A"/>
                 </a:solidFill>
@@ -8254,26 +8254,26 @@
           </a:p>
           <a:p>
             <a:pPr>
-              <a:defRPr sz="1100">
-                <a:solidFill>
-                  <a:srgbClr val="0F172A"/>
-                </a:solidFill>
-              </a:defRPr>
-            </a:pPr>
-            <a:r>
-              <a:t>  2. In speech processing, Conv1D with kernel size 15 makes physical sense along the time dimension (spanning ~240 ms of speech), whereas across a 24-element global summary vector, kernel 15 covers 62.5% of the entire representation in a single hop!</a:t>
-            </a:r>
-          </a:p>
-          <a:p>
-            <a:pPr>
-              <a:defRPr sz="1100">
-                <a:solidFill>
-                  <a:srgbClr val="0F172A"/>
-                </a:solidFill>
-              </a:defRPr>
-            </a:pPr>
-            <a:r>
-              <a:t>  3. However, the paper never specifies the audio clip duration, STFT hop size, or framing required to yield exactly 144 frames.</a:t>
+              <a:defRPr sz="1050">
+                <a:solidFill>
+                  <a:srgbClr val="0F172A"/>
+                </a:solidFill>
+              </a:defRPr>
+            </a:pPr>
+            <a:r>
+              <a:t>  2. In speech processing, Conv1D with kernel size 15 along the temporal axis (~240 ms) has acoustic validity, whereas on a 24-dim summary vector, kernel 15 spans 62.5% of all features in one stride.</a:t>
+            </a:r>
+          </a:p>
+          <a:p>
+            <a:pPr>
+              <a:defRPr sz="1050">
+                <a:solidFill>
+                  <a:srgbClr val="0F172A"/>
+                </a:solidFill>
+              </a:defRPr>
+            </a:pPr>
+            <a:r>
+              <a:t>  3. Crucially, both 144-input representations below are OUR INTERPRETATION and are NOT CONFIRMED by the published paper, which omits clip duration, framing parameters, and hop sizes.</a:t>
             </a:r>
           </a:p>
         </p:txBody>
@@ -8353,7 +8353,7 @@
               </a:defRPr>
             </a:pPr>
             <a:r>
-              <a:t>Two Grounded Interpretations Implemented</a:t>
+              <a:t>Two Reverse-Engineered Interpretations</a:t>
             </a:r>
           </a:p>
         </p:txBody>
@@ -8381,7 +8381,7 @@
           <a:lstStyle/>
           <a:p>
             <a:pPr>
-              <a:defRPr sz="1100">
+              <a:defRPr sz="1050">
                 <a:solidFill>
                   <a:srgbClr val="0F172A"/>
                 </a:solidFill>
@@ -8393,107 +8393,107 @@
           </a:p>
           <a:p>
             <a:pPr>
-              <a:defRPr sz="1100">
-                <a:solidFill>
-                  <a:srgbClr val="0F172A"/>
-                </a:solidFill>
-              </a:defRPr>
-            </a:pPr>
-            <a:r>
-              <a:t>  - Representation: Matrix of shape (144, n_coeff).</a:t>
-            </a:r>
-          </a:p>
-          <a:p>
-            <a:pPr>
-              <a:defRPr sz="1100">
-                <a:solidFill>
-                  <a:srgbClr val="0F172A"/>
-                </a:solidFill>
-              </a:defRPr>
-            </a:pPr>
-            <a:r>
-              <a:t>  - Construction: Audio fixed to 2.3 seconds (or center-cropped/padded) at 16 kHz with hop length 256 samples (16 ms) -&gt; exactly 144 frames.</a:t>
-            </a:r>
-          </a:p>
-          <a:p>
-            <a:pPr>
-              <a:defRPr sz="1100">
-                <a:solidFill>
-                  <a:srgbClr val="0F172A"/>
-                </a:solidFill>
-              </a:defRPr>
-            </a:pPr>
-            <a:r>
-              <a:t>  - Conv1D slides over time; 4 pooling layers reduce time: 144 -&gt; 72 -&gt; 36 -&gt; 18 -&gt; 9. Flatten layer yields 9 x 64 = 576 units into Dense(120).</a:t>
-            </a:r>
-          </a:p>
-          <a:p>
-            <a:pPr>
-              <a:defRPr sz="1100">
-                <a:solidFill>
-                  <a:srgbClr val="0F172A"/>
-                </a:solidFill>
-              </a:defRPr>
-            </a:pPr>
-          </a:p>
-          <a:p>
-            <a:pPr>
-              <a:defRPr sz="1100">
-                <a:solidFill>
-                  <a:srgbClr val="0F172A"/>
-                </a:solidFill>
-              </a:defRPr>
-            </a:pPr>
-            <a:r>
-              <a:t>• Interpretation 2: 'stats144' (Multi-Stream Statistics)</a:t>
-            </a:r>
-          </a:p>
-          <a:p>
-            <a:pPr>
-              <a:defRPr sz="1100">
-                <a:solidFill>
-                  <a:srgbClr val="0F172A"/>
-                </a:solidFill>
-              </a:defRPr>
-            </a:pPr>
-            <a:r>
-              <a:t>  - Representation: 1D vector of shape (144, 1).</a:t>
-            </a:r>
-          </a:p>
-          <a:p>
-            <a:pPr>
-              <a:defRPr sz="1100">
-                <a:solidFill>
-                  <a:srgbClr val="0F172A"/>
-                </a:solidFill>
-              </a:defRPr>
-            </a:pPr>
-            <a:r>
-              <a:t>  - Construction: Static + Delta + Delta-Delta trajectories across coefficients, summarized via statistical moments (mean, std, min, max).</a:t>
-            </a:r>
-          </a:p>
-          <a:p>
-            <a:pPr>
-              <a:defRPr sz="1100">
-                <a:solidFill>
-                  <a:srgbClr val="0F172A"/>
-                </a:solidFill>
-              </a:defRPr>
-            </a:pPr>
-            <a:r>
-              <a:t>  - For 24 coeffs: 24 x 3 streams x 2 stats = 144 features.</a:t>
-            </a:r>
-          </a:p>
-          <a:p>
-            <a:pPr>
-              <a:defRPr sz="1100">
-                <a:solidFill>
-                  <a:srgbClr val="0F172A"/>
-                </a:solidFill>
-              </a:defRPr>
-            </a:pPr>
-            <a:r>
-              <a:t>  - For 12 coeffs: 12 x 3 streams x 4 stats = 144 features.</a:t>
+              <a:defRPr sz="1050">
+                <a:solidFill>
+                  <a:srgbClr val="0F172A"/>
+                </a:solidFill>
+              </a:defRPr>
+            </a:pPr>
+            <a:r>
+              <a:t>  - Shape: Matrix of shape (144, n_coeff) at hop size 256 samples (16 ms @ 16 kHz).</a:t>
+            </a:r>
+          </a:p>
+          <a:p>
+            <a:pPr>
+              <a:defRPr sz="1050">
+                <a:solidFill>
+                  <a:srgbClr val="0F172A"/>
+                </a:solidFill>
+              </a:defRPr>
+            </a:pPr>
+            <a:r>
+              <a:t>  - Variable Duration Handling: Clips with &lt;144 frames are zero-padded at the end; clips with &gt;144 frames are center-cropped to 144 frames.</a:t>
+            </a:r>
+          </a:p>
+          <a:p>
+            <a:pPr>
+              <a:defRPr sz="1050">
+                <a:solidFill>
+                  <a:srgbClr val="0F172A"/>
+                </a:solidFill>
+              </a:defRPr>
+            </a:pPr>
+            <a:r>
+              <a:t>  - 4 Conv1D+Pool layers reduce time: 144 -&gt; 72 -&gt; 36 -&gt; 18 -&gt; 9. Flatten yields 9 x 64 = 576 units into Dense(120).</a:t>
+            </a:r>
+          </a:p>
+          <a:p>
+            <a:pPr>
+              <a:defRPr sz="1050">
+                <a:solidFill>
+                  <a:srgbClr val="0F172A"/>
+                </a:solidFill>
+              </a:defRPr>
+            </a:pPr>
+          </a:p>
+          <a:p>
+            <a:pPr>
+              <a:defRPr sz="1050">
+                <a:solidFill>
+                  <a:srgbClr val="0F172A"/>
+                </a:solidFill>
+              </a:defRPr>
+            </a:pPr>
+            <a:r>
+              <a:t>• Interpretation 2: 'stats144' (Multi-Stream Summary Vector)</a:t>
+            </a:r>
+          </a:p>
+          <a:p>
+            <a:pPr>
+              <a:defRPr sz="1050">
+                <a:solidFill>
+                  <a:srgbClr val="0F172A"/>
+                </a:solidFill>
+              </a:defRPr>
+            </a:pPr>
+            <a:r>
+              <a:t>  - Shape: 1D vector of shape (144, 1) combining static + delta + delta-delta.</a:t>
+            </a:r>
+          </a:p>
+          <a:p>
+            <a:pPr>
+              <a:defRPr sz="1050">
+                <a:solidFill>
+                  <a:srgbClr val="0F172A"/>
+                </a:solidFill>
+              </a:defRPr>
+            </a:pPr>
+            <a:r>
+              <a:t>  - 12 coeffs: 36 trajectories x 4 stats (mean, std, min, max) = exactly 144 values.</a:t>
+            </a:r>
+          </a:p>
+          <a:p>
+            <a:pPr>
+              <a:defRPr sz="1050">
+                <a:solidFill>
+                  <a:srgbClr val="0F172A"/>
+                </a:solidFill>
+              </a:defRPr>
+            </a:pPr>
+            <a:r>
+              <a:t>  - 24 coeffs: 72 trajectories x 2 stats (mean, std) = exactly 144 values.</a:t>
+            </a:r>
+          </a:p>
+          <a:p>
+            <a:pPr>
+              <a:defRPr sz="1050">
+                <a:solidFill>
+                  <a:srgbClr val="0F172A"/>
+                </a:solidFill>
+              </a:defRPr>
+            </a:pPr>
+            <a:r>
+              <a:t>  - 30 coeffs: 90 trajectories x 2 stats = 180 values, truncated to first 144 values.</a:t>
             </a:r>
           </a:p>
         </p:txBody>
@@ -8716,7 +8716,7 @@
               </a:defRPr>
             </a:pPr>
             <a:r>
-              <a:t>  - In fact, the temporal frames144 format performs significantly WORSE than our 24/48/60 baseline.</a:t>
+              <a:t>  - On 11 of 12 configurations, the 24/48/60 baseline achieved higher test accuracy than both 144-input representations (only on MFMC-12 unaugmented did 144 formats score higher: 57-60% vs 51.7%).</a:t>
             </a:r>
           </a:p>
           <a:p>
@@ -8749,100 +8749,88 @@
               </a:defRPr>
             </a:pPr>
             <a:r>
-              <a:t>  - 12 Coeffs Baseline (24-dim): 64.2% ± 4.4%</a:t>
-            </a:r>
-          </a:p>
-          <a:p>
-            <a:pPr>
-              <a:defRPr sz="1100">
-                <a:solidFill>
-                  <a:srgbClr val="0F172A"/>
-                </a:solidFill>
-              </a:defRPr>
-            </a:pPr>
-            <a:r>
-              <a:t>  - 12 Coeffs frames144 (144x12): 56.4% ± 2.0% (Drop: -7.8%)</a:t>
-            </a:r>
-          </a:p>
-          <a:p>
-            <a:pPr>
-              <a:defRPr sz="1100">
-                <a:solidFill>
-                  <a:srgbClr val="0F172A"/>
-                </a:solidFill>
-              </a:defRPr>
-            </a:pPr>
-            <a:r>
-              <a:t>  - 24 Coeffs Baseline (48-dim): 70.1% ± 3.8%</a:t>
-            </a:r>
-          </a:p>
-          <a:p>
-            <a:pPr>
-              <a:defRPr sz="1100">
-                <a:solidFill>
-                  <a:srgbClr val="0F172A"/>
-                </a:solidFill>
-              </a:defRPr>
-            </a:pPr>
-            <a:r>
-              <a:t>  - 24 Coeffs frames144 (144x24): 54.8% ± 5.2% (Drop: -15.3%)</a:t>
-            </a:r>
-          </a:p>
-          <a:p>
-            <a:pPr>
-              <a:defRPr sz="1100">
-                <a:solidFill>
-                  <a:srgbClr val="0F172A"/>
-                </a:solidFill>
-              </a:defRPr>
-            </a:pPr>
-          </a:p>
-          <a:p>
-            <a:pPr>
-              <a:defRPr sz="1100">
-                <a:solidFill>
-                  <a:srgbClr val="0F172A"/>
-                </a:solidFill>
-              </a:defRPr>
-            </a:pPr>
-            <a:r>
-              <a:t>• Why Does frames144 Degrade Performance?</a:t>
-            </a:r>
-          </a:p>
-          <a:p>
-            <a:pPr>
-              <a:defRPr sz="1100">
-                <a:solidFill>
-                  <a:srgbClr val="0F172A"/>
-                </a:solidFill>
-              </a:defRPr>
-            </a:pPr>
-            <a:r>
-              <a:t>  - Severe Overfitting: Without global pooling, the model has 576 units feeding into Dense(120).</a:t>
-            </a:r>
-          </a:p>
-          <a:p>
-            <a:pPr>
-              <a:defRPr sz="1100">
-                <a:solidFill>
-                  <a:srgbClr val="0F172A"/>
-                </a:solidFill>
-              </a:defRPr>
-            </a:pPr>
-            <a:r>
-              <a:t>  - On small datasets (321 training clips), Conv1D rapidly memorizes exact frame sequences, reaching 100% training accuracy within 15 epochs while validation diverges.</a:t>
-            </a:r>
-          </a:p>
-          <a:p>
-            <a:pPr>
-              <a:defRPr sz="1100">
-                <a:solidFill>
-                  <a:srgbClr val="0F172A"/>
-                </a:solidFill>
-              </a:defRPr>
-            </a:pPr>
-            <a:r>
-              <a:t>  - Baseline summary statistics (mean+std) provide implicit temporal regularization.</a:t>
+              <a:t>  - 12 Coeffs: Baseline (24-dim) 64.2% ± 2.4% vs. frames144 56.4% ± 1.9%</a:t>
+            </a:r>
+          </a:p>
+          <a:p>
+            <a:pPr>
+              <a:defRPr sz="1100">
+                <a:solidFill>
+                  <a:srgbClr val="0F172A"/>
+                </a:solidFill>
+              </a:defRPr>
+            </a:pPr>
+            <a:r>
+              <a:t>  - 24 Coeffs: Baseline (48-dim) 69.2% ± 4.3% vs. frames144 54.8% ± 5.1%</a:t>
+            </a:r>
+          </a:p>
+          <a:p>
+            <a:pPr>
+              <a:defRPr sz="1100">
+                <a:solidFill>
+                  <a:srgbClr val="0F172A"/>
+                </a:solidFill>
+              </a:defRPr>
+            </a:pPr>
+            <a:r>
+              <a:t>  - 30 Coeffs: Baseline (60-dim) 71.0% ± 0.9% vs. frames144 57.0% ± 3.7%</a:t>
+            </a:r>
+          </a:p>
+          <a:p>
+            <a:pPr>
+              <a:defRPr sz="1100">
+                <a:solidFill>
+                  <a:srgbClr val="0F172A"/>
+                </a:solidFill>
+              </a:defRPr>
+            </a:pPr>
+          </a:p>
+          <a:p>
+            <a:pPr>
+              <a:defRPr sz="1100">
+                <a:solidFill>
+                  <a:srgbClr val="0F172A"/>
+                </a:solidFill>
+              </a:defRPr>
+            </a:pPr>
+            <a:r>
+              <a:t>• Overfitting Hypothesis (Not Tested):</a:t>
+            </a:r>
+          </a:p>
+          <a:p>
+            <a:pPr>
+              <a:defRPr sz="1100">
+                <a:solidFill>
+                  <a:srgbClr val="0F172A"/>
+                </a:solidFill>
+              </a:defRPr>
+            </a:pPr>
+            <a:r>
+              <a:t>  - We hypothesize that frames144 rapidly memorizes sequences due to 576 units into Dense(120), as training accuracy saturated to ~100% within 15 epochs.</a:t>
+            </a:r>
+          </a:p>
+          <a:p>
+            <a:pPr>
+              <a:defRPr sz="1100">
+                <a:solidFill>
+                  <a:srgbClr val="0F172A"/>
+                </a:solidFill>
+              </a:defRPr>
+            </a:pPr>
+            <a:r>
+              <a:t>  - However, this remains a hypothesis as controlled regularization sweeps were not conducted.</a:t>
+            </a:r>
+          </a:p>
+          <a:p>
+            <a:pPr>
+              <a:defRPr sz="1100">
+                <a:solidFill>
+                  <a:srgbClr val="0F172A"/>
+                </a:solidFill>
+              </a:defRPr>
+            </a:pPr>
+            <a:r>
+              <a:t>  - Global pooling (mean+std) provides effective implicit regularization.</a:t>
             </a:r>
           </a:p>
         </p:txBody>
@@ -9840,43 +9828,43 @@
               </a:defRPr>
             </a:pPr>
             <a:r>
-              <a:t>  - EmoDB (German, 7 cls): 66–71% (None) -&gt; 71–72% (Ver A) [Paper: 97.2% / 97.5%]</a:t>
-            </a:r>
-          </a:p>
-          <a:p>
-            <a:pPr>
-              <a:defRPr sz="1100">
-                <a:solidFill>
-                  <a:srgbClr val="0F172A"/>
-                </a:solidFill>
-              </a:defRPr>
-            </a:pPr>
-            <a:r>
-              <a:t>  - AESDD (Greek, 5 cls): 57–61% (None) -&gt; 77–79% (Ver A) [Paper: 97.8% / 99.2%]</a:t>
-            </a:r>
-          </a:p>
-          <a:p>
-            <a:pPr>
-              <a:defRPr sz="1100">
-                <a:solidFill>
-                  <a:srgbClr val="0F172A"/>
-                </a:solidFill>
-              </a:defRPr>
-            </a:pPr>
-            <a:r>
-              <a:t>  - CAFE (French, 7 cls): 46–50% (None) -&gt; 40–55% (Ver A) [Paper: 99.5%]</a:t>
-            </a:r>
-          </a:p>
-          <a:p>
-            <a:pPr>
-              <a:defRPr sz="1100">
-                <a:solidFill>
-                  <a:srgbClr val="0F172A"/>
-                </a:solidFill>
-              </a:defRPr>
-            </a:pPr>
-            <a:r>
-              <a:t>  - MESD (Spanish, 6 cls): 64–66% (None) -&gt; 67–69% (Ver A) [Paper: 96.9%]</a:t>
+              <a:t>  - EmoDB (German, 7 cls): 66–71% (None) -&gt; 71–72% (Ver A) [Paper: 86.9% / 97.2%]</a:t>
+            </a:r>
+          </a:p>
+          <a:p>
+            <a:pPr>
+              <a:defRPr sz="1100">
+                <a:solidFill>
+                  <a:srgbClr val="0F172A"/>
+                </a:solidFill>
+              </a:defRPr>
+            </a:pPr>
+            <a:r>
+              <a:t>  - AESDD (Greek, 5 cls): 54–57% (None) -&gt; 58–64% (Ver A) [Paper: 95.0% / 97.8%]</a:t>
+            </a:r>
+          </a:p>
+          <a:p>
+            <a:pPr>
+              <a:defRPr sz="1100">
+                <a:solidFill>
+                  <a:srgbClr val="0F172A"/>
+                </a:solidFill>
+              </a:defRPr>
+            </a:pPr>
+            <a:r>
+              <a:t>  - CAFE (French, 7 cls): 46–50% (None) -&gt; 40–55% (Ver A) [Paper: 93.6% / 99.5%]</a:t>
+            </a:r>
+          </a:p>
+          <a:p>
+            <a:pPr>
+              <a:defRPr sz="1100">
+                <a:solidFill>
+                  <a:srgbClr val="0F172A"/>
+                </a:solidFill>
+              </a:defRPr>
+            </a:pPr>
+            <a:r>
+              <a:t>  - MESD (Spanish, 6 cls): 64–66% (None) -&gt; 67–69% (Ver A) [Paper: 94.2% / 96.9%]</a:t>
             </a:r>
           </a:p>
           <a:p>
@@ -9909,19 +9897,19 @@
               </a:defRPr>
             </a:pPr>
             <a:r>
-              <a:t>  - Clean Version A augmentation provides moderate gains on AESDD (5 classes), but minor or negative shifts on EmoDB, CAFE, and MESD.</a:t>
-            </a:r>
-          </a:p>
-          <a:p>
-            <a:pPr>
-              <a:defRPr sz="1100">
-                <a:solidFill>
-                  <a:srgbClr val="0F172A"/>
-                </a:solidFill>
-              </a:defRPr>
-            </a:pPr>
-            <a:r>
-              <a:t>  - Across datasets, many augmentation differences remain within random seed variance (seed std ranges from ±2% to ±7%).</a:t>
+              <a:t>  - Clean Version A augmentation shifts test accuracy by -7% to +11% across corpora.</a:t>
+            </a:r>
+          </a:p>
+          <a:p>
+            <a:pPr>
+              <a:defRPr sz="1100">
+                <a:solidFill>
+                  <a:srgbClr val="0F172A"/>
+                </a:solidFill>
+              </a:defRPr>
+            </a:pPr>
+            <a:r>
+              <a:t>  - Across datasets, most augmentation differences are not distinguishable from seed variation (seed std ranges from ±2% to ±11%).</a:t>
             </a:r>
           </a:p>
           <a:p>
@@ -10409,7 +10397,7 @@
               </a:defRPr>
             </a:pPr>
             <a:r>
-              <a:t>Strict Disjoint Partitioning Design</a:t>
+              <a:t>Rotating Speaker-Disjoint Fold Design</a:t>
             </a:r>
           </a:p>
         </p:txBody>
@@ -10437,203 +10425,170 @@
           <a:lstStyle/>
           <a:p>
             <a:pPr>
-              <a:defRPr sz="1100">
-                <a:solidFill>
-                  <a:srgbClr val="0F172A"/>
-                </a:solidFill>
-              </a:defRPr>
-            </a:pPr>
-            <a:r>
-              <a:t>• Disjoint Speaker Partitions Built:</a:t>
-            </a:r>
-          </a:p>
-          <a:p>
-            <a:pPr>
-              <a:defRPr sz="1100">
-                <a:solidFill>
-                  <a:srgbClr val="0F172A"/>
-                </a:solidFill>
-              </a:defRPr>
-            </a:pPr>
-            <a:r>
-              <a:t>  - EmoDB (10 speakers):</a:t>
-            </a:r>
-          </a:p>
-          <a:p>
-            <a:pPr>
-              <a:defRPr sz="1100">
-                <a:solidFill>
-                  <a:srgbClr val="0F172A"/>
-                </a:solidFill>
-              </a:defRPr>
-            </a:pPr>
-            <a:r>
-              <a:t>    * Train: 6 speakers (~60% clips)</a:t>
-            </a:r>
-          </a:p>
-          <a:p>
-            <a:pPr>
-              <a:defRPr sz="1100">
-                <a:solidFill>
-                  <a:srgbClr val="0F172A"/>
-                </a:solidFill>
-              </a:defRPr>
-            </a:pPr>
-            <a:r>
-              <a:t>    * Val: 2 speakers (~20% clips)</a:t>
-            </a:r>
-          </a:p>
-          <a:p>
-            <a:pPr>
-              <a:defRPr sz="1100">
-                <a:solidFill>
-                  <a:srgbClr val="0F172A"/>
-                </a:solidFill>
-              </a:defRPr>
-            </a:pPr>
-            <a:r>
-              <a:t>    * Test: 2 speakers (~20% clips)</a:t>
-            </a:r>
-          </a:p>
-          <a:p>
-            <a:pPr>
-              <a:defRPr sz="1100">
-                <a:solidFill>
-                  <a:srgbClr val="0F172A"/>
-                </a:solidFill>
-              </a:defRPr>
-            </a:pPr>
-            <a:r>
-              <a:t>  - CAFE (12 speakers):</a:t>
-            </a:r>
-          </a:p>
-          <a:p>
-            <a:pPr>
-              <a:defRPr sz="1100">
-                <a:solidFill>
-                  <a:srgbClr val="0F172A"/>
-                </a:solidFill>
-              </a:defRPr>
-            </a:pPr>
-            <a:r>
-              <a:t>    * Train: 8 speakers (624 clips)</a:t>
-            </a:r>
-          </a:p>
-          <a:p>
-            <a:pPr>
-              <a:defRPr sz="1100">
-                <a:solidFill>
-                  <a:srgbClr val="0F172A"/>
-                </a:solidFill>
-              </a:defRPr>
-            </a:pPr>
-            <a:r>
-              <a:t>    * Val: 2 speakers (156 clips)</a:t>
-            </a:r>
-          </a:p>
-          <a:p>
-            <a:pPr>
-              <a:defRPr sz="1100">
-                <a:solidFill>
-                  <a:srgbClr val="0F172A"/>
-                </a:solidFill>
-              </a:defRPr>
-            </a:pPr>
-            <a:r>
-              <a:t>    * Test: 2 speakers (156 clips)</a:t>
-            </a:r>
-          </a:p>
-          <a:p>
-            <a:pPr>
-              <a:defRPr sz="1100">
-                <a:solidFill>
-                  <a:srgbClr val="0F172A"/>
-                </a:solidFill>
-              </a:defRPr>
-            </a:pPr>
-            <a:r>
-              <a:t>  - AESDD (5 speakers):</a:t>
-            </a:r>
-          </a:p>
-          <a:p>
-            <a:pPr>
-              <a:defRPr sz="1100">
-                <a:solidFill>
-                  <a:srgbClr val="0F172A"/>
-                </a:solidFill>
-              </a:defRPr>
-            </a:pPr>
-            <a:r>
-              <a:t>    * Train: 3 speakers (300 clips)</a:t>
-            </a:r>
-          </a:p>
-          <a:p>
-            <a:pPr>
-              <a:defRPr sz="1100">
-                <a:solidFill>
-                  <a:srgbClr val="0F172A"/>
-                </a:solidFill>
-              </a:defRPr>
-            </a:pPr>
-            <a:r>
-              <a:t>    * Val: 1 speaker (100 clips)</a:t>
-            </a:r>
-          </a:p>
-          <a:p>
-            <a:pPr>
-              <a:defRPr sz="1100">
-                <a:solidFill>
-                  <a:srgbClr val="0F172A"/>
-                </a:solidFill>
-              </a:defRPr>
-            </a:pPr>
-            <a:r>
-              <a:t>    * Test: 1 speaker (100 clips)</a:t>
-            </a:r>
-          </a:p>
-          <a:p>
-            <a:pPr>
-              <a:defRPr sz="1100">
-                <a:solidFill>
-                  <a:srgbClr val="0F172A"/>
-                </a:solidFill>
-              </a:defRPr>
-            </a:pPr>
-          </a:p>
-          <a:p>
-            <a:pPr>
-              <a:defRPr sz="1100">
-                <a:solidFill>
-                  <a:srgbClr val="0F172A"/>
-                </a:solidFill>
-              </a:defRPr>
-            </a:pPr>
-            <a:r>
-              <a:t>• Verification:</a:t>
-            </a:r>
-          </a:p>
-          <a:p>
-            <a:pPr>
-              <a:defRPr sz="1100">
-                <a:solidFill>
-                  <a:srgbClr val="0F172A"/>
-                </a:solidFill>
-              </a:defRPr>
-            </a:pPr>
-            <a:r>
-              <a:t>  - Set intersection: Train ∩ Val = ∅, Train ∩ Test = ∅, Val ∩ Test = ∅.</a:t>
-            </a:r>
-          </a:p>
-          <a:p>
-            <a:pPr>
-              <a:defRPr sz="1100">
-                <a:solidFill>
-                  <a:srgbClr val="0F172A"/>
-                </a:solidFill>
-              </a:defRPr>
-            </a:pPr>
-            <a:r>
-              <a:t>  - Verified 100% disjointness via automated unit tests.</a:t>
+              <a:defRPr sz="1050">
+                <a:solidFill>
+                  <a:srgbClr val="0F172A"/>
+                </a:solidFill>
+              </a:defRPr>
+            </a:pPr>
+            <a:r>
+              <a:t>• Rotating Speaker-Disjoint Folds:</a:t>
+            </a:r>
+          </a:p>
+          <a:p>
+            <a:pPr>
+              <a:defRPr sz="1050">
+                <a:solidFill>
+                  <a:srgbClr val="0F172A"/>
+                </a:solidFill>
+              </a:defRPr>
+            </a:pPr>
+            <a:r>
+              <a:t>  - EmoDB (10 speakers: 5M, 5F) -&gt; 5 Folds:</a:t>
+            </a:r>
+          </a:p>
+          <a:p>
+            <a:pPr>
+              <a:defRPr sz="1050">
+                <a:solidFill>
+                  <a:srgbClr val="0F172A"/>
+                </a:solidFill>
+              </a:defRPr>
+            </a:pPr>
+            <a:r>
+              <a:t>    * Test: 2 speakers (1M, 1F, ~20%)</a:t>
+            </a:r>
+          </a:p>
+          <a:p>
+            <a:pPr>
+              <a:defRPr sz="1050">
+                <a:solidFill>
+                  <a:srgbClr val="0F172A"/>
+                </a:solidFill>
+              </a:defRPr>
+            </a:pPr>
+            <a:r>
+              <a:t>    * Val: 2 speakers from remaining (1M, 1F, ~20%)</a:t>
+            </a:r>
+          </a:p>
+          <a:p>
+            <a:pPr>
+              <a:defRPr sz="1050">
+                <a:solidFill>
+                  <a:srgbClr val="0F172A"/>
+                </a:solidFill>
+              </a:defRPr>
+            </a:pPr>
+            <a:r>
+              <a:t>    * Train: remaining 6 speakers (3M, 3F, ~60%)</a:t>
+            </a:r>
+          </a:p>
+          <a:p>
+            <a:pPr>
+              <a:defRPr sz="1050">
+                <a:solidFill>
+                  <a:srgbClr val="0F172A"/>
+                </a:solidFill>
+              </a:defRPr>
+            </a:pPr>
+            <a:r>
+              <a:t>  - CAFE (12 speakers: 6M, 6F) -&gt; 6 Folds:</a:t>
+            </a:r>
+          </a:p>
+          <a:p>
+            <a:pPr>
+              <a:defRPr sz="1050">
+                <a:solidFill>
+                  <a:srgbClr val="0F172A"/>
+                </a:solidFill>
+              </a:defRPr>
+            </a:pPr>
+            <a:r>
+              <a:t>    * Test: 2 speakers (1M, 1F, 156 clips, 16.7%)</a:t>
+            </a:r>
+          </a:p>
+          <a:p>
+            <a:pPr>
+              <a:defRPr sz="1050">
+                <a:solidFill>
+                  <a:srgbClr val="0F172A"/>
+                </a:solidFill>
+              </a:defRPr>
+            </a:pPr>
+            <a:r>
+              <a:t>    * Val: 2 speakers from remaining (156 clips, 16.7%)</a:t>
+            </a:r>
+          </a:p>
+          <a:p>
+            <a:pPr>
+              <a:defRPr sz="1050">
+                <a:solidFill>
+                  <a:srgbClr val="0F172A"/>
+                </a:solidFill>
+              </a:defRPr>
+            </a:pPr>
+            <a:r>
+              <a:t>    * Train: remaining 8 speakers (624 clips, 66.7%)</a:t>
+            </a:r>
+          </a:p>
+          <a:p>
+            <a:pPr>
+              <a:defRPr sz="1050">
+                <a:solidFill>
+                  <a:srgbClr val="0F172A"/>
+                </a:solidFill>
+              </a:defRPr>
+            </a:pPr>
+            <a:r>
+              <a:t>  - AESDD (5 core actors) -&gt; 5 Folds:</a:t>
+            </a:r>
+          </a:p>
+          <a:p>
+            <a:pPr>
+              <a:defRPr sz="1050">
+                <a:solidFill>
+                  <a:srgbClr val="0F172A"/>
+                </a:solidFill>
+              </a:defRPr>
+            </a:pPr>
+            <a:r>
+              <a:t>    * Test: 1 core actor (100 clips, 20%)</a:t>
+            </a:r>
+          </a:p>
+          <a:p>
+            <a:pPr>
+              <a:defRPr sz="1050">
+                <a:solidFill>
+                  <a:srgbClr val="0F172A"/>
+                </a:solidFill>
+              </a:defRPr>
+            </a:pPr>
+            <a:r>
+              <a:t>    * Val: 1 core actor from remaining (100 clips, 20%)</a:t>
+            </a:r>
+          </a:p>
+          <a:p>
+            <a:pPr>
+              <a:defRPr sz="1050">
+                <a:solidFill>
+                  <a:srgbClr val="0F172A"/>
+                </a:solidFill>
+              </a:defRPr>
+            </a:pPr>
+            <a:r>
+              <a:t>    * Train: 3 core actors + Actor 6 takes (exactly 300 clips, 60%)</a:t>
+            </a:r>
+          </a:p>
+          <a:p>
+            <a:pPr>
+              <a:defRPr sz="1050">
+                <a:solidFill>
+                  <a:srgbClr val="0F172A"/>
+                </a:solidFill>
+              </a:defRPr>
+            </a:pPr>
+            <a:r>
+              <a:t>    * Total: 300 train + 100 val + 100 test = 500 clips.</a:t>
             </a:r>
           </a:p>
         </p:txBody>
@@ -10856,7 +10811,7 @@
               </a:defRPr>
             </a:pPr>
             <a:r>
-              <a:t>  - Grouped Partitioning: Speakers never shared across train, val, and test.</a:t>
+              <a:t>  - Rotating Folds: Speakers never shared between train, val, and test.</a:t>
             </a:r>
           </a:p>
           <a:p>
@@ -10880,133 +10835,157 @@
               </a:defRPr>
             </a:pPr>
             <a:r>
-              <a:t>  - Single-Pass Test: Test speakers evaluated exactly once on frozen weights.</a:t>
-            </a:r>
-          </a:p>
-          <a:p>
-            <a:pPr>
-              <a:defRPr sz="1100">
-                <a:solidFill>
-                  <a:srgbClr val="0F172A"/>
-                </a:solidFill>
-              </a:defRPr>
-            </a:pPr>
-            <a:r>
-              <a:t>  - MESD Excluded: Lacks individual speaker IDs (demographic cohorts only).</a:t>
-            </a:r>
-          </a:p>
-          <a:p>
-            <a:pPr>
-              <a:defRPr sz="1100">
-                <a:solidFill>
-                  <a:srgbClr val="0F172A"/>
-                </a:solidFill>
-              </a:defRPr>
-            </a:pPr>
-          </a:p>
-          <a:p>
-            <a:pPr>
-              <a:defRPr sz="1100">
-                <a:solidFill>
-                  <a:srgbClr val="0F172A"/>
-                </a:solidFill>
-              </a:defRPr>
-            </a:pPr>
-            <a:r>
-              <a:t>• Experimental Matrix (108 Runs Total):</a:t>
-            </a:r>
-          </a:p>
-          <a:p>
-            <a:pPr>
-              <a:defRPr sz="1100">
-                <a:solidFill>
-                  <a:srgbClr val="0F172A"/>
-                </a:solidFill>
-              </a:defRPr>
-            </a:pPr>
-            <a:r>
-              <a:t>  - 3 Corpora: EmoDB, CAFE, AESDD</a:t>
-            </a:r>
-          </a:p>
-          <a:p>
-            <a:pPr>
-              <a:defRPr sz="1100">
-                <a:solidFill>
-                  <a:srgbClr val="0F172A"/>
-                </a:solidFill>
-              </a:defRPr>
-            </a:pPr>
-            <a:r>
-              <a:t>  - 2 Features: MFCC vs. MFMC (12, 24, 30 coeffs)</a:t>
-            </a:r>
-          </a:p>
-          <a:p>
-            <a:pPr>
-              <a:defRPr sz="1100">
-                <a:solidFill>
-                  <a:srgbClr val="0F172A"/>
-                </a:solidFill>
-              </a:defRPr>
-            </a:pPr>
-            <a:r>
-              <a:t>  - 2 Setups: None vs. Version A (clean 5x)</a:t>
-            </a:r>
-          </a:p>
-          <a:p>
-            <a:pPr>
-              <a:defRPr sz="1100">
-                <a:solidFill>
-                  <a:srgbClr val="0F172A"/>
-                </a:solidFill>
-              </a:defRPr>
-            </a:pPr>
-            <a:r>
-              <a:t>  - 3 Speaker Assignment Seeds: 42, 43, 44</a:t>
-            </a:r>
-          </a:p>
-          <a:p>
-            <a:pPr>
-              <a:defRPr sz="1100">
-                <a:solidFill>
-                  <a:srgbClr val="0F172A"/>
-                </a:solidFill>
-              </a:defRPr>
-            </a:pPr>
-          </a:p>
-          <a:p>
-            <a:pPr>
-              <a:defRPr sz="1100">
-                <a:solidFill>
-                  <a:srgbClr val="0F172A"/>
-                </a:solidFill>
-              </a:defRPr>
-            </a:pPr>
-            <a:r>
-              <a:t>• Execution &amp; Runtime Estimate:</a:t>
-            </a:r>
-          </a:p>
-          <a:p>
-            <a:pPr>
-              <a:defRPr sz="1100">
-                <a:solidFill>
-                  <a:srgbClr val="0F172A"/>
-                </a:solidFill>
-              </a:defRPr>
-            </a:pPr>
-            <a:r>
-              <a:t>  - Estimated total runtime: ~14–16 minutes on CPU.</a:t>
-            </a:r>
-          </a:p>
-          <a:p>
-            <a:pPr>
-              <a:defRPr sz="1100">
-                <a:solidFill>
-                  <a:srgbClr val="0F172A"/>
-                </a:solidFill>
-              </a:defRPr>
-            </a:pPr>
-            <a:r>
-              <a:t>  - Status: Paused awaiting supervisor review and confirmation.</a:t>
+              <a:t>  - Single-Pass Test: Test fold evaluated once on frozen weights.</a:t>
+            </a:r>
+          </a:p>
+          <a:p>
+            <a:pPr>
+              <a:defRPr sz="1100">
+                <a:solidFill>
+                  <a:srgbClr val="0F172A"/>
+                </a:solidFill>
+              </a:defRPr>
+            </a:pPr>
+            <a:r>
+              <a:t>  - MESD Excluded: Demographic cohorts only, no individual speaker IDs.</a:t>
+            </a:r>
+          </a:p>
+          <a:p>
+            <a:pPr>
+              <a:defRPr sz="1100">
+                <a:solidFill>
+                  <a:srgbClr val="0F172A"/>
+                </a:solidFill>
+              </a:defRPr>
+            </a:pPr>
+          </a:p>
+          <a:p>
+            <a:pPr>
+              <a:defRPr sz="1100">
+                <a:solidFill>
+                  <a:srgbClr val="0F172A"/>
+                </a:solidFill>
+              </a:defRPr>
+            </a:pPr>
+            <a:r>
+              <a:t>• Experimental Matrix (384 Runs Total):</a:t>
+            </a:r>
+          </a:p>
+          <a:p>
+            <a:pPr>
+              <a:defRPr sz="1100">
+                <a:solidFill>
+                  <a:srgbClr val="0F172A"/>
+                </a:solidFill>
+              </a:defRPr>
+            </a:pPr>
+            <a:r>
+              <a:t>  - 3 Corpora: EmoDB (5 folds), CAFE (6 folds), AESDD (5 folds)</a:t>
+            </a:r>
+          </a:p>
+          <a:p>
+            <a:pPr>
+              <a:defRPr sz="1100">
+                <a:solidFill>
+                  <a:srgbClr val="0F172A"/>
+                </a:solidFill>
+              </a:defRPr>
+            </a:pPr>
+            <a:r>
+              <a:t>  - Coefficients: 24 and 30 only (dropped 12)</a:t>
+            </a:r>
+          </a:p>
+          <a:p>
+            <a:pPr>
+              <a:defRPr sz="1100">
+                <a:solidFill>
+                  <a:srgbClr val="0F172A"/>
+                </a:solidFill>
+              </a:defRPr>
+            </a:pPr>
+            <a:r>
+              <a:t>  - Features: MFCC &amp; MFMC (2) | Setups: None &amp; Ver A (2)</a:t>
+            </a:r>
+          </a:p>
+          <a:p>
+            <a:pPr>
+              <a:defRPr sz="1100">
+                <a:solidFill>
+                  <a:srgbClr val="0F172A"/>
+                </a:solidFill>
+              </a:defRPr>
+            </a:pPr>
+            <a:r>
+              <a:t>  - Seeds: 42, 43, 44 (3)</a:t>
+            </a:r>
+          </a:p>
+          <a:p>
+            <a:pPr>
+              <a:defRPr sz="1100">
+                <a:solidFill>
+                  <a:srgbClr val="0F172A"/>
+                </a:solidFill>
+              </a:defRPr>
+            </a:pPr>
+            <a:r>
+              <a:t>  - Formula: (5 + 6 + 5) folds x 2 feats x 2 coeffs x 2 setups x 3 seeds = 384 runs.</a:t>
+            </a:r>
+          </a:p>
+          <a:p>
+            <a:pPr>
+              <a:defRPr sz="1100">
+                <a:solidFill>
+                  <a:srgbClr val="0F172A"/>
+                </a:solidFill>
+              </a:defRPr>
+            </a:pPr>
+          </a:p>
+          <a:p>
+            <a:pPr>
+              <a:defRPr sz="1100">
+                <a:solidFill>
+                  <a:srgbClr val="0F172A"/>
+                </a:solidFill>
+              </a:defRPr>
+            </a:pPr>
+            <a:r>
+              <a:t>• Runtime Estimate &amp; Metric Reporting:</a:t>
+            </a:r>
+          </a:p>
+          <a:p>
+            <a:pPr>
+              <a:defRPr sz="1100">
+                <a:solidFill>
+                  <a:srgbClr val="0F172A"/>
+                </a:solidFill>
+              </a:defRPr>
+            </a:pPr>
+            <a:r>
+              <a:t>  - EmoDB: ~17m | AESDD: ~53m | CAFE: ~78m -&gt; Total: ~2.5 hours (~148m).</a:t>
+            </a:r>
+          </a:p>
+          <a:p>
+            <a:pPr>
+              <a:defRPr sz="1100">
+                <a:solidFill>
+                  <a:srgbClr val="0F172A"/>
+                </a:solidFill>
+              </a:defRPr>
+            </a:pPr>
+            <a:r>
+              <a:t>  - Reporting: Mean ± Std over folds for each configuration.</a:t>
+            </a:r>
+          </a:p>
+          <a:p>
+            <a:pPr>
+              <a:defRPr sz="1100">
+                <a:solidFill>
+                  <a:srgbClr val="0F172A"/>
+                </a:solidFill>
+              </a:defRPr>
+            </a:pPr>
+            <a:r>
+              <a:t>  - Status: Paused awaiting supervisor approval before running.</a:t>
             </a:r>
           </a:p>
         </p:txBody>

</xml_diff>

<commit_message>
Complete Week 5: regularization study, acoustic augmentations, statistical tests, final reproduction report, and slide deck
</commit_message>
<xml_diff>
--- a/Week4_Status.pptx
+++ b/Week4_Status.pptx
@@ -606,7 +606,7 @@
           </a:p>
           <a:p>
             <a:r>
-              <a:t>To synthesize our findings: First, the 144-input format does not close the gap; in fact, temporal framing makes overfitting worse. Second, clean Gaussian noise augmentation provides minimal benefit across four different languages. And third, speaker identity leakage explains why random splits report high numbers: when speakers are separated, accuracy drops by up to 25%. Our reproduction study demonstrates that the published 97.2% figure relies on methodological flaws—specifically pre-split augmentation and speaker overlap.</a:t>
+              <a:t>To synthesize our findings: First, the 144-input format does not close the gap; in fact, temporal framing makes overfitting worse. Second, clean Gaussian noise augmentation provides minimal benefit across four different languages. And third, speaker identity leakage explains why random splits report high numbers: when speakers are separated, accuracy drops by 8.2 to 21.2 percentage points (average -16.5 points). Our reproduction study shows that the published figures are consistent with methodological artifacts—specifically pre-split augmentation and speaker overlap.</a:t>
             </a:r>
           </a:p>
         </p:txBody>
@@ -1497,7 +1497,7 @@
           </a:p>
           <a:p>
             <a:r>
-              <a:t>On Slide 9, we outline the exact protocol for Task 3 before launching the runs. We evaluate EmoDB, CAFE, and AESDD across 108 experimental configurations. MESD is explicitly excluded because it only has demographic groups rather than individual speaker identities. Models will be selected strictly on validation speakers, and test speakers will be evaluated once on the frozen best checkpoint. The estimated runtime is approximately 14 to 16 minutes. We are paused here awaiting your confirmation before beginning execution.</a:t>
+              <a:t>Slide 9 reveals our most critical evaluation finding: the dramatic collapse in performance when models are evaluated on unseen speakers. Across all three corpora, enforcing strict speaker disjointness causes test accuracy to drop by 8.2 to 21.2 percentage points (average -16.5 points). On EmoDB, accuracy drops from 71% to around 51%; on AESDD, from 57% to around 38%; and on CAFE, from 50% to around 35%. Furthermore, clean Version A Gaussian noise augmentation provides negligible protection against this speaker shift. This strongly suggests that in random stratified splits, the 1D-CNN relies substantially on speaker acoustic characteristics rather than learning pure emotion patterns.</a:t>
             </a:r>
           </a:p>
         </p:txBody>
@@ -4966,19 +4966,19 @@
               </a:defRPr>
             </a:pPr>
             <a:r>
-              <a:t>   - Across German (EmoDB), French (CAFE), Greek (AESDD), and Spanish (MESD), clean Version A augmentation shifts test accuracy by only -2% to +5%.</a:t>
-            </a:r>
-          </a:p>
-          <a:p>
-            <a:pPr>
-              <a:defRPr sz="1100">
-                <a:solidFill>
-                  <a:srgbClr val="0F172A"/>
-                </a:solidFill>
-              </a:defRPr>
-            </a:pPr>
-            <a:r>
-              <a:t>   - Most shifts fall within the random seed standard deviation (±2% to ±6%), and are not distinguishable from seed variation.</a:t>
+              <a:t>   - Across German (EmoDB), French (CAFE), Greek (AESDD), and Spanish (MESD), clean Version A augmentation shifts test accuracy by -6.2 to +8.9 percentage points (stratified) and -2.6 to +9.7 percentage points (speaker-independent).</a:t>
+            </a:r>
+          </a:p>
+          <a:p>
+            <a:pPr>
+              <a:defRPr sz="1100">
+                <a:solidFill>
+                  <a:srgbClr val="0F172A"/>
+                </a:solidFill>
+              </a:defRPr>
+            </a:pPr>
+            <a:r>
+              <a:t>   - Most shifts fall within the random seed or cross-fold standard deviation (±2% to ±11%), and are not distinguishable from noise.</a:t>
             </a:r>
           </a:p>
           <a:p>
@@ -5011,31 +5011,31 @@
               </a:defRPr>
             </a:pPr>
             <a:r>
-              <a:t>3. Speaker Identity Memorization is the Dominant Hidden Factor in High Reported Accuracies</a:t>
-            </a:r>
-          </a:p>
-          <a:p>
-            <a:pPr>
-              <a:defRPr sz="1100">
-                <a:solidFill>
-                  <a:srgbClr val="0F172A"/>
-                </a:solidFill>
-              </a:defRPr>
-            </a:pPr>
-            <a:r>
-              <a:t>   - Evaluating on unseen speakers causes a sharp 12% to 25% accuracy collapse across all corpora.</a:t>
-            </a:r>
-          </a:p>
-          <a:p>
-            <a:pPr>
-              <a:defRPr sz="1100">
-                <a:solidFill>
-                  <a:srgbClr val="0F172A"/>
-                </a:solidFill>
-              </a:defRPr>
-            </a:pPr>
-            <a:r>
-              <a:t>   - When combined with data leakage (augmenting before splitting, +15-20%), models easily reach artificial 90%+ scores without true emotion generalization.</a:t>
+              <a:t>3. Speaker Identity Confound Explains a Substantial Portion of the Performance Gap</a:t>
+            </a:r>
+          </a:p>
+          <a:p>
+            <a:pPr>
+              <a:defRPr sz="1100">
+                <a:solidFill>
+                  <a:srgbClr val="0F172A"/>
+                </a:solidFill>
+              </a:defRPr>
+            </a:pPr>
+            <a:r>
+              <a:t>   - Evaluating on unseen speakers causes an immediate 8.2 to 21.2 percentage point drop across all 24 configurations (average drop: -16.5 points).</a:t>
+            </a:r>
+          </a:p>
+          <a:p>
+            <a:pPr>
+              <a:defRPr sz="1100">
+                <a:solidFill>
+                  <a:srgbClr val="0F172A"/>
+                </a:solidFill>
+              </a:defRPr>
+            </a:pPr>
+            <a:r>
+              <a:t>   - Data is consistent with the hypothesis that published ~97-99% figures reflect speaker overlap and potential pre-split augmentation leakage rather than pure emotion recognition.</a:t>
             </a:r>
           </a:p>
           <a:p>
@@ -5068,7 +5068,19 @@
               </a:defRPr>
             </a:pPr>
             <a:r>
-              <a:t>   - Scientific honesty requires reporting genuine leak-free numbers: this 1D-CNN architecture achieves ~65-72% in speaker-dependent conditions, and ~48-55% in speaker-independent conditions.</a:t>
+              <a:t>   - Scientific honesty requires reporting genuine leak-free numbers: this 1D-CNN architecture achieves ~63-72% on EmoDB (40-65% across other corpora) in stratified splits, and ~47-55% on EmoDB (~31-46% on AESDD and CAFE) in speaker-independent folds.</a:t>
+            </a:r>
+          </a:p>
+          <a:p>
+            <a:pPr>
+              <a:defRPr sz="1100">
+                <a:solidFill>
+                  <a:srgbClr val="0F172A"/>
+                </a:solidFill>
+              </a:defRPr>
+            </a:pPr>
+            <a:r>
+              <a:t>   *Footnote: Speaker-independent std is across folds; stratified std is across seeds; they are not directly comparable.*</a:t>
             </a:r>
           </a:p>
         </p:txBody>
@@ -6975,7 +6987,7 @@
               </a:defRPr>
             </a:pPr>
             <a:r>
-              <a:t>  - Augmenting before splitting (Version B) leaked 98.5% of source clips into training, yielding 80–89% accuracy.</a:t>
+              <a:t>  - Augmenting before splitting (Version B) leaked 95.9% of test clip source recordings into training (98.5% of all source clips present in train), yielding 80–89% accuracy.</a:t>
             </a:r>
           </a:p>
           <a:p>
@@ -8494,6 +8506,18 @@
             </a:pPr>
             <a:r>
               <a:t>  - 30 coeffs: 90 trajectories x 2 stats = 180 values, truncated to first 144 values.</a:t>
+            </a:r>
+          </a:p>
+          <a:p>
+            <a:pPr>
+              <a:defRPr sz="1050">
+                <a:solidFill>
+                  <a:srgbClr val="0F172A"/>
+                </a:solidFill>
+              </a:defRPr>
+            </a:pPr>
+            <a:r>
+              <a:t>  - Note: Recipe differs across coefficient sizes (4 stats at 12, 2 at 24, truncated at 30), so columns are not like-for-like.</a:t>
             </a:r>
           </a:p>
         </p:txBody>
@@ -9235,7 +9259,7 @@
               </a:defRPr>
             </a:pPr>
             <a:r>
-              <a:t>• AESDD (Att-HACK Greek):</a:t>
+              <a:t>• AESDD (Acted Emotional Speech Dynamic Database, Greek):</a:t>
             </a:r>
           </a:p>
           <a:p>
@@ -9897,19 +9921,19 @@
               </a:defRPr>
             </a:pPr>
             <a:r>
-              <a:t>  - Clean Version A augmentation shifts test accuracy by -7% to +11% across corpora.</a:t>
-            </a:r>
-          </a:p>
-          <a:p>
-            <a:pPr>
-              <a:defRPr sz="1100">
-                <a:solidFill>
-                  <a:srgbClr val="0F172A"/>
-                </a:solidFill>
-              </a:defRPr>
-            </a:pPr>
-            <a:r>
-              <a:t>  - Across datasets, most augmentation differences are not distinguishable from seed variation (seed std ranges from ±2% to ±11%).</a:t>
+              <a:t>  - Clean Version A augmentation shifts test accuracy by -6.2 to +8.9 percentage points across 24/30-coeff stratified conditions (-6.2 to +11.9 pts including 12-coeff EmoDB).</a:t>
+            </a:r>
+          </a:p>
+          <a:p>
+            <a:pPr>
+              <a:defRPr sz="1100">
+                <a:solidFill>
+                  <a:srgbClr val="0F172A"/>
+                </a:solidFill>
+              </a:defRPr>
+            </a:pPr>
+            <a:r>
+              <a:t>  - Across datasets, augmentation differences remain within random seed standard deviation (±2% to ±11%), and are not distinguishable from seed variation.</a:t>
             </a:r>
           </a:p>
           <a:p>
@@ -9922,6 +9946,18 @@
             </a:pPr>
             <a:r>
               <a:t>  - The paper's claimed peak accuracies (~97–99%) were not replicated under our implementation across any of the four benchmarks.</a:t>
+            </a:r>
+          </a:p>
+          <a:p>
+            <a:pPr>
+              <a:defRPr sz="1100">
+                <a:solidFill>
+                  <a:srgbClr val="0F172A"/>
+                </a:solidFill>
+              </a:defRPr>
+            </a:pPr>
+            <a:r>
+              <a:t>  *Footnote: Stratified standard deviations are computed across random seeds (N=3).*</a:t>
             </a:r>
           </a:p>
         </p:txBody>
@@ -10684,7 +10720,7 @@
               </a:defRPr>
             </a:pPr>
             <a:r>
-              <a:t>Task 3: Speaker-Independent Experimental Design &amp; Protocol</a:t>
+              <a:t>Task 3 Results: Speaker-Independent Generalization Collapse</a:t>
             </a:r>
           </a:p>
         </p:txBody>
@@ -10764,7 +10800,7 @@
               </a:defRPr>
             </a:pPr>
             <a:r>
-              <a:t>Protocol &amp; Execution Parameters</a:t>
+              <a:t>Speaker-Disjoint Generalization Findings</a:t>
             </a:r>
           </a:p>
         </p:txBody>
@@ -10792,43 +10828,55 @@
           <a:lstStyle/>
           <a:p>
             <a:pPr>
-              <a:defRPr sz="1100">
-                <a:solidFill>
-                  <a:srgbClr val="0F172A"/>
-                </a:solidFill>
-              </a:defRPr>
-            </a:pPr>
-            <a:r>
-              <a:t>• Strict Experimental Guardrails:</a:t>
-            </a:r>
-          </a:p>
-          <a:p>
-            <a:pPr>
-              <a:defRPr sz="1100">
-                <a:solidFill>
-                  <a:srgbClr val="0F172A"/>
-                </a:solidFill>
-              </a:defRPr>
-            </a:pPr>
-            <a:r>
-              <a:t>  - Rotating Folds: Speakers never shared between train, val, and test.</a:t>
-            </a:r>
-          </a:p>
-          <a:p>
-            <a:pPr>
-              <a:defRPr sz="1100">
-                <a:solidFill>
-                  <a:srgbClr val="0F172A"/>
-                </a:solidFill>
-              </a:defRPr>
-            </a:pPr>
-            <a:r>
-              <a:t>  - Model Selection: Best checkpoint selected SOLELY on validation speakers.</a:t>
-            </a:r>
-          </a:p>
-          <a:p>
-            <a:pPr>
-              <a:defRPr sz="1100">
+              <a:defRPr sz="1050">
+                <a:solidFill>
+                  <a:srgbClr val="0F172A"/>
+                </a:solidFill>
+              </a:defRPr>
+            </a:pPr>
+            <a:r>
+              <a:t>• Strict Experimental Guardrails (384 Runs Total):</a:t>
+            </a:r>
+          </a:p>
+          <a:p>
+            <a:pPr>
+              <a:defRPr sz="1050">
+                <a:solidFill>
+                  <a:srgbClr val="0F172A"/>
+                </a:solidFill>
+              </a:defRPr>
+            </a:pPr>
+            <a:r>
+              <a:t>  - Rotating Folds: EmoDB (5 folds), AESDD (5 folds), CAFE (6 folds).</a:t>
+            </a:r>
+          </a:p>
+          <a:p>
+            <a:pPr>
+              <a:defRPr sz="1050">
+                <a:solidFill>
+                  <a:srgbClr val="0F172A"/>
+                </a:solidFill>
+              </a:defRPr>
+            </a:pPr>
+            <a:r>
+              <a:t>  - Zero Speaker Overlap: Speakers strictly segregated across Train, Val, and Test.</a:t>
+            </a:r>
+          </a:p>
+          <a:p>
+            <a:pPr>
+              <a:defRPr sz="1050">
+                <a:solidFill>
+                  <a:srgbClr val="0F172A"/>
+                </a:solidFill>
+              </a:defRPr>
+            </a:pPr>
+            <a:r>
+              <a:t>  - Model Selection: Best checkpoint selected SOLELY on unseen validation speakers.</a:t>
+            </a:r>
+          </a:p>
+          <a:p>
+            <a:pPr>
+              <a:defRPr sz="1050">
                 <a:solidFill>
                   <a:srgbClr val="0F172A"/>
                 </a:solidFill>
@@ -10840,152 +10888,128 @@
           </a:p>
           <a:p>
             <a:pPr>
-              <a:defRPr sz="1100">
-                <a:solidFill>
-                  <a:srgbClr val="0F172A"/>
-                </a:solidFill>
-              </a:defRPr>
-            </a:pPr>
-            <a:r>
-              <a:t>  - MESD Excluded: Demographic cohorts only, no individual speaker IDs.</a:t>
-            </a:r>
-          </a:p>
-          <a:p>
-            <a:pPr>
-              <a:defRPr sz="1100">
-                <a:solidFill>
-                  <a:srgbClr val="0F172A"/>
-                </a:solidFill>
-              </a:defRPr>
-            </a:pPr>
-          </a:p>
-          <a:p>
-            <a:pPr>
-              <a:defRPr sz="1100">
-                <a:solidFill>
-                  <a:srgbClr val="0F172A"/>
-                </a:solidFill>
-              </a:defRPr>
-            </a:pPr>
-            <a:r>
-              <a:t>• Experimental Matrix (384 Runs Total):</a:t>
-            </a:r>
-          </a:p>
-          <a:p>
-            <a:pPr>
-              <a:defRPr sz="1100">
-                <a:solidFill>
-                  <a:srgbClr val="0F172A"/>
-                </a:solidFill>
-              </a:defRPr>
-            </a:pPr>
-            <a:r>
-              <a:t>  - 3 Corpora: EmoDB (5 folds), CAFE (6 folds), AESDD (5 folds)</a:t>
-            </a:r>
-          </a:p>
-          <a:p>
-            <a:pPr>
-              <a:defRPr sz="1100">
-                <a:solidFill>
-                  <a:srgbClr val="0F172A"/>
-                </a:solidFill>
-              </a:defRPr>
-            </a:pPr>
-            <a:r>
-              <a:t>  - Coefficients: 24 and 30 only (dropped 12)</a:t>
-            </a:r>
-          </a:p>
-          <a:p>
-            <a:pPr>
-              <a:defRPr sz="1100">
-                <a:solidFill>
-                  <a:srgbClr val="0F172A"/>
-                </a:solidFill>
-              </a:defRPr>
-            </a:pPr>
-            <a:r>
-              <a:t>  - Features: MFCC &amp; MFMC (2) | Setups: None &amp; Ver A (2)</a:t>
-            </a:r>
-          </a:p>
-          <a:p>
-            <a:pPr>
-              <a:defRPr sz="1100">
-                <a:solidFill>
-                  <a:srgbClr val="0F172A"/>
-                </a:solidFill>
-              </a:defRPr>
-            </a:pPr>
-            <a:r>
-              <a:t>  - Seeds: 42, 43, 44 (3)</a:t>
-            </a:r>
-          </a:p>
-          <a:p>
-            <a:pPr>
-              <a:defRPr sz="1100">
-                <a:solidFill>
-                  <a:srgbClr val="0F172A"/>
-                </a:solidFill>
-              </a:defRPr>
-            </a:pPr>
-            <a:r>
-              <a:t>  - Formula: (5 + 6 + 5) folds x 2 feats x 2 coeffs x 2 setups x 3 seeds = 384 runs.</a:t>
-            </a:r>
-          </a:p>
-          <a:p>
-            <a:pPr>
-              <a:defRPr sz="1100">
-                <a:solidFill>
-                  <a:srgbClr val="0F172A"/>
-                </a:solidFill>
-              </a:defRPr>
-            </a:pPr>
-          </a:p>
-          <a:p>
-            <a:pPr>
-              <a:defRPr sz="1100">
-                <a:solidFill>
-                  <a:srgbClr val="0F172A"/>
-                </a:solidFill>
-              </a:defRPr>
-            </a:pPr>
-            <a:r>
-              <a:t>• Runtime Estimate &amp; Metric Reporting:</a:t>
-            </a:r>
-          </a:p>
-          <a:p>
-            <a:pPr>
-              <a:defRPr sz="1100">
-                <a:solidFill>
-                  <a:srgbClr val="0F172A"/>
-                </a:solidFill>
-              </a:defRPr>
-            </a:pPr>
-            <a:r>
-              <a:t>  - EmoDB: ~17m | AESDD: ~53m | CAFE: ~78m -&gt; Total: ~2.5 hours (~148m).</a:t>
-            </a:r>
-          </a:p>
-          <a:p>
-            <a:pPr>
-              <a:defRPr sz="1100">
-                <a:solidFill>
-                  <a:srgbClr val="0F172A"/>
-                </a:solidFill>
-              </a:defRPr>
-            </a:pPr>
-            <a:r>
-              <a:t>  - Reporting: Mean ± Std over folds for each configuration.</a:t>
-            </a:r>
-          </a:p>
-          <a:p>
-            <a:pPr>
-              <a:defRPr sz="1100">
-                <a:solidFill>
-                  <a:srgbClr val="0F172A"/>
-                </a:solidFill>
-              </a:defRPr>
-            </a:pPr>
-            <a:r>
-              <a:t>  - Status: Paused awaiting supervisor approval before running.</a:t>
+              <a:defRPr sz="1050">
+                <a:solidFill>
+                  <a:srgbClr val="0F172A"/>
+                </a:solidFill>
+              </a:defRPr>
+            </a:pPr>
+          </a:p>
+          <a:p>
+            <a:pPr>
+              <a:defRPr sz="1050">
+                <a:solidFill>
+                  <a:srgbClr val="0F172A"/>
+                </a:solidFill>
+              </a:defRPr>
+            </a:pPr>
+            <a:r>
+              <a:t>• Observed Speaker Generalization Collapse (30 Coeffs):</a:t>
+            </a:r>
+          </a:p>
+          <a:p>
+            <a:pPr>
+              <a:defRPr sz="1050">
+                <a:solidFill>
+                  <a:srgbClr val="0F172A"/>
+                </a:solidFill>
+              </a:defRPr>
+            </a:pPr>
+            <a:r>
+              <a:t>  - EmoDB (German, 7 cls): Drops from 71.0% (stratified) to ~48-52% (speaker-disjoint).</a:t>
+            </a:r>
+          </a:p>
+          <a:p>
+            <a:pPr>
+              <a:defRPr sz="1050">
+                <a:solidFill>
+                  <a:srgbClr val="0F172A"/>
+                </a:solidFill>
+              </a:defRPr>
+            </a:pPr>
+            <a:r>
+              <a:t>  - AESDD (Greek, 5 cls): Drops from 54-57% (stratified) to ~35-42% (speaker-disjoint).</a:t>
+            </a:r>
+          </a:p>
+          <a:p>
+            <a:pPr>
+              <a:defRPr sz="1050">
+                <a:solidFill>
+                  <a:srgbClr val="0F172A"/>
+                </a:solidFill>
+              </a:defRPr>
+            </a:pPr>
+            <a:r>
+              <a:t>  - CAFE (French, 7 cls): Drops from 46-50% (stratified) to ~30-38% (speaker-disjoint).</a:t>
+            </a:r>
+          </a:p>
+          <a:p>
+            <a:pPr>
+              <a:defRPr sz="1050">
+                <a:solidFill>
+                  <a:srgbClr val="0F172A"/>
+                </a:solidFill>
+              </a:defRPr>
+            </a:pPr>
+          </a:p>
+          <a:p>
+            <a:pPr>
+              <a:defRPr sz="1050">
+                <a:solidFill>
+                  <a:srgbClr val="0F172A"/>
+                </a:solidFill>
+              </a:defRPr>
+            </a:pPr>
+            <a:r>
+              <a:t>• Key Methodological Findings:</a:t>
+            </a:r>
+          </a:p>
+          <a:p>
+            <a:pPr>
+              <a:defRPr sz="1050">
+                <a:solidFill>
+                  <a:srgbClr val="0F172A"/>
+                </a:solidFill>
+              </a:defRPr>
+            </a:pPr>
+            <a:r>
+              <a:t>  - Removing speaker identity overlap causes an immediate 8.2 to 21.2 percentage point drop across all 24 configurations (average drop: -16.5 points).</a:t>
+            </a:r>
+          </a:p>
+          <a:p>
+            <a:pPr>
+              <a:defRPr sz="1050">
+                <a:solidFill>
+                  <a:srgbClr val="0F172A"/>
+                </a:solidFill>
+              </a:defRPr>
+            </a:pPr>
+            <a:r>
+              <a:t>  - Gaussian noise augmentation provides negligible defense against speaker shift; shifts are within cross-fold variation.</a:t>
+            </a:r>
+          </a:p>
+          <a:p>
+            <a:pPr>
+              <a:defRPr sz="1050">
+                <a:solidFill>
+                  <a:srgbClr val="0F172A"/>
+                </a:solidFill>
+              </a:defRPr>
+            </a:pPr>
+            <a:r>
+              <a:t>  - Strongly suggests the 1D-CNN relies substantially on speaker acoustic characteristics under random splits.</a:t>
+            </a:r>
+          </a:p>
+          <a:p>
+            <a:pPr>
+              <a:defRPr sz="1050">
+                <a:solidFill>
+                  <a:srgbClr val="0F172A"/>
+                </a:solidFill>
+              </a:defRPr>
+            </a:pPr>
+            <a:r>
+              <a:t>  *Footnote: Speaker-independent std is across folds (N=5/6); stratified std is across seeds (N=3); not directly comparable.*</a:t>
             </a:r>
           </a:p>
         </p:txBody>
@@ -11065,148 +11089,35 @@
               </a:defRPr>
             </a:pPr>
             <a:r>
-              <a:t>Scientific Hypotheses to Test</a:t>
-            </a:r>
-          </a:p>
-        </p:txBody>
-      </p:sp>
-      <p:sp>
-        <p:nvSpPr>
-          <p:cNvPr id="9" name="TextBox 8"/>
-          <p:cNvSpPr txBox="1"/>
+              <a:t>Stratified vs. Speaker-Independent Comparison</a:t>
+            </a:r>
+          </a:p>
+        </p:txBody>
+      </p:sp>
+      <p:pic>
+        <p:nvPicPr>
+          <p:cNvPr id="9" name="Picture 8" descr="week4_plot_speaker_independent.png"/>
+          <p:cNvPicPr>
+            <a:picLocks noChangeAspect="1"/>
+          </p:cNvPicPr>
           <p:nvPr/>
-        </p:nvSpPr>
+        </p:nvPicPr>
+        <p:blipFill>
+          <a:blip r:embed="rId2"/>
+          <a:stretch>
+            <a:fillRect/>
+          </a:stretch>
+        </p:blipFill>
         <p:spPr>
           <a:xfrm>
             <a:off x="6400800" y="2103120"/>
-            <a:ext cx="4846320" cy="4023360"/>
+            <a:ext cx="4846320" cy="1795149"/>
           </a:xfrm>
           <a:prstGeom prst="rect">
             <a:avLst/>
           </a:prstGeom>
-          <a:noFill/>
-        </p:spPr>
-        <p:txBody>
-          <a:bodyPr wrap="square">
-            <a:spAutoFit/>
-          </a:bodyPr>
-          <a:lstStyle/>
-          <a:p>
-            <a:pPr>
-              <a:defRPr sz="1100">
-                <a:solidFill>
-                  <a:srgbClr val="0F172A"/>
-                </a:solidFill>
-              </a:defRPr>
-            </a:pPr>
-            <a:r>
-              <a:t>• Expected Generalization Drop:</a:t>
-            </a:r>
-          </a:p>
-          <a:p>
-            <a:pPr>
-              <a:defRPr sz="1100">
-                <a:solidFill>
-                  <a:srgbClr val="0F172A"/>
-                </a:solidFill>
-              </a:defRPr>
-            </a:pPr>
-            <a:r>
-              <a:t>  - Removing speaker identity overlap is expected to drop test accuracy by 15% to 25% across all corpora.</a:t>
-            </a:r>
-          </a:p>
-          <a:p>
-            <a:pPr>
-              <a:defRPr sz="1100">
-                <a:solidFill>
-                  <a:srgbClr val="0F172A"/>
-                </a:solidFill>
-              </a:defRPr>
-            </a:pPr>
-            <a:r>
-              <a:t>  - Tests whether the 1D-CNN is genuinely learning emotion representations or acting as a speaker biometric classifier.</a:t>
-            </a:r>
-          </a:p>
-          <a:p>
-            <a:pPr>
-              <a:defRPr sz="1100">
-                <a:solidFill>
-                  <a:srgbClr val="0F172A"/>
-                </a:solidFill>
-              </a:defRPr>
-            </a:pPr>
-          </a:p>
-          <a:p>
-            <a:pPr>
-              <a:defRPr sz="1100">
-                <a:solidFill>
-                  <a:srgbClr val="0F172A"/>
-                </a:solidFill>
-              </a:defRPr>
-            </a:pPr>
-            <a:r>
-              <a:t>• Does Gaussian Noise Protect Against Speaker Shift?</a:t>
-            </a:r>
-          </a:p>
-          <a:p>
-            <a:pPr>
-              <a:defRPr sz="1100">
-                <a:solidFill>
-                  <a:srgbClr val="0F172A"/>
-                </a:solidFill>
-              </a:defRPr>
-            </a:pPr>
-            <a:r>
-              <a:t>  - Hypothesis: Additive Gaussian noise corrupts acoustics uniformly but does not alter fundamental speaker identity (pitch range, vocal tract length).</a:t>
-            </a:r>
-          </a:p>
-          <a:p>
-            <a:pPr>
-              <a:defRPr sz="1100">
-                <a:solidFill>
-                  <a:srgbClr val="0F172A"/>
-                </a:solidFill>
-              </a:defRPr>
-            </a:pPr>
-            <a:r>
-              <a:t>  - Clean Version A augmentation is therefore expected to show minimal resilience against speaker shift.</a:t>
-            </a:r>
-          </a:p>
-          <a:p>
-            <a:pPr>
-              <a:defRPr sz="1100">
-                <a:solidFill>
-                  <a:srgbClr val="0F172A"/>
-                </a:solidFill>
-              </a:defRPr>
-            </a:pPr>
-          </a:p>
-          <a:p>
-            <a:pPr>
-              <a:defRPr sz="1100">
-                <a:solidFill>
-                  <a:srgbClr val="0F172A"/>
-                </a:solidFill>
-              </a:defRPr>
-            </a:pPr>
-            <a:r>
-              <a:t>• Methodological Implication for Paper:</a:t>
-            </a:r>
-          </a:p>
-          <a:p>
-            <a:pPr>
-              <a:defRPr sz="1100">
-                <a:solidFill>
-                  <a:srgbClr val="0F172A"/>
-                </a:solidFill>
-              </a:defRPr>
-            </a:pPr>
-            <a:r>
-              <a:t>  - The paper's ~97–99% figures rely on random splits (speaker overlap) combined with data leakage.</a:t>
-            </a:r>
-          </a:p>
-        </p:txBody>
-      </p:sp>
+        </p:spPr>
+      </p:pic>
     </p:spTree>
   </p:cSld>
   <p:clrMapOvr>

</xml_diff>